<commit_message>
[WP] preparing for presentation
</commit_message>
<xml_diff>
--- a/WebProgramming/6.Termin/state-management-react.pptx
+++ b/WebProgramming/6.Termin/state-management-react.pptx
@@ -4,6 +4,9 @@
   <p:sldMasterIdLst>
     <p:sldMasterId id="2147483648" r:id="rId1"/>
   </p:sldMasterIdLst>
+  <p:notesMasterIdLst>
+    <p:notesMasterId r:id="rId17"/>
+  </p:notesMasterIdLst>
   <p:sldIdLst>
     <p:sldId id="256" r:id="rId2"/>
     <p:sldId id="257" r:id="rId3"/>
@@ -21,10 +24,7 @@
     <p:sldId id="269" r:id="rId15"/>
     <p:sldId id="270" r:id="rId16"/>
   </p:sldIdLst>
-  <p:notesMasterIdLst>
-    <p:notesMasterId r:id="rId17"/>
-  </p:notesMasterIdLst>
-  <p:sldSz cx="9144000" cy="5143500"/>
+  <p:sldSz cx="9144000" cy="5143500" type="screen16x9"/>
   <p:notesSz cx="5143500" cy="9144000"/>
   <p:defaultTextStyle>
     <a:lvl1pPr marL="0" algn="l" defTabSz="914400" rtl="0" eaLnBrk="1" latinLnBrk="0" hangingPunct="1">
@@ -118,6 +118,11 @@
       </a:defRPr>
     </a:lvl9pPr>
   </p:defaultTextStyle>
+  <p:extLst>
+    <p:ext uri="{EFAFB233-063F-42B5-8137-9DF3F51BA10A}">
+      <p15:sldGuideLst xmlns:p15="http://schemas.microsoft.com/office/powerpoint/2012/main"/>
+    </p:ext>
+  </p:extLst>
 </p:presentation>
 </file>
 
@@ -143,234 +148,10 @@
           <a:chExt cx="0" cy="0"/>
         </a:xfrm>
       </p:grpSpPr>
-      <p:sp>
-        <p:nvSpPr>
-          <p:cNvPr id="2" name="Header Placeholder 1"/>
-          <p:cNvSpPr>
-            <a:spLocks noGrp="1"/>
-          </p:cNvSpPr>
-          <p:nvPr>
-            <p:ph type="hdr" sz="quarter"/>
-          </p:nvPr>
-        </p:nvSpPr>
-        <p:spPr>
-          <a:xfrm>
-            <a:off x="0" y="0"/>
-            <a:ext cx="2971800" cy="458788"/>
-          </a:xfrm>
-          <a:prstGeom prst="rect">
-            <a:avLst/>
-          </a:prstGeom>
-        </p:spPr>
-        <p:txBody>
-          <a:bodyPr vert="horz" lIns="91440" tIns="45720" rIns="91440" bIns="45720" rtlCol="0"/>
-          <a:lstStyle>
-            <a:lvl1pPr algn="l">
-              <a:defRPr sz="1200"/>
-            </a:lvl1pPr>
-          </a:lstStyle>
-          <a:p>
-            <a:endParaRPr lang="en-US"/>
-          </a:p>
-        </p:txBody>
-      </p:sp>
-      <p:sp>
-        <p:nvSpPr>
-          <p:cNvPr id="3" name="Date Placeholder 2"/>
-          <p:cNvSpPr>
-            <a:spLocks noGrp="1"/>
-          </p:cNvSpPr>
-          <p:nvPr>
-            <p:ph type="dt" idx="1"/>
-          </p:nvPr>
-        </p:nvSpPr>
-        <p:spPr>
-          <a:xfrm>
-            <a:off x="3884613" y="0"/>
-            <a:ext cx="2971800" cy="458788"/>
-          </a:xfrm>
-          <a:prstGeom prst="rect">
-            <a:avLst/>
-          </a:prstGeom>
-        </p:spPr>
-        <p:txBody>
-          <a:bodyPr vert="horz" lIns="91440" tIns="45720" rIns="91440" bIns="45720" rtlCol="0"/>
-          <a:lstStyle>
-            <a:lvl1pPr algn="r">
-              <a:defRPr sz="1200"/>
-            </a:lvl1pPr>
-          </a:lstStyle>
-          <a:p>
-            <a:fld id="{5282F153-3F37-0F45-9E97-73ACFA13230C}" type="datetimeFigureOut">
-              <a:rPr lang="en-US"/>
-              <a:t>7/23/19</a:t>
-            </a:fld>
-            <a:endParaRPr lang="en-US"/>
-          </a:p>
-        </p:txBody>
-      </p:sp>
-      <p:sp>
-        <p:nvSpPr>
-          <p:cNvPr id="4" name="Slide Image Placeholder 3"/>
-          <p:cNvSpPr>
-            <a:spLocks noGrp="1" noRot="1" noChangeAspect="1"/>
-          </p:cNvSpPr>
-          <p:nvPr>
-            <p:ph type="sldImg" idx="2"/>
-          </p:nvPr>
-        </p:nvSpPr>
-        <p:spPr>
-          <a:xfrm>
-            <a:off x="685800" y="1143000"/>
-            <a:ext cx="5486400" cy="3086100"/>
-          </a:xfrm>
-          <a:prstGeom prst="rect">
-            <a:avLst/>
-          </a:prstGeom>
-          <a:noFill/>
-          <a:ln w="12700">
-            <a:solidFill>
-              <a:prstClr val="black"/>
-            </a:solidFill>
-          </a:ln>
-        </p:spPr>
-        <p:txBody>
-          <a:bodyPr vert="horz" lIns="91440" tIns="45720" rIns="91440" bIns="45720" rtlCol="0" anchor="ctr"/>
-          <a:lstStyle/>
-          <a:p>
-            <a:endParaRPr lang="en-US"/>
-          </a:p>
-        </p:txBody>
-      </p:sp>
-      <p:sp>
-        <p:nvSpPr>
-          <p:cNvPr id="5" name="Notes Placeholder 4"/>
-          <p:cNvSpPr>
-            <a:spLocks noGrp="1"/>
-          </p:cNvSpPr>
-          <p:nvPr>
-            <p:ph type="body" sz="quarter" idx="3"/>
-          </p:nvPr>
-        </p:nvSpPr>
-        <p:spPr>
-          <a:xfrm>
-            <a:off x="685800" y="4400550"/>
-            <a:ext cx="5486400" cy="3600450"/>
-          </a:xfrm>
-          <a:prstGeom prst="rect">
-            <a:avLst/>
-          </a:prstGeom>
-        </p:spPr>
-        <p:txBody>
-          <a:bodyPr vert="horz" lIns="91440" tIns="45720" rIns="91440" bIns="45720" rtlCol="0"/>
-          <a:lstStyle/>
-          <a:p>
-            <a:pPr lvl="0"/>
-            <a:r>
-              <a:rPr lang="en-US"/>
-              <a:t>Click to edit Master text styles</a:t>
-            </a:r>
-          </a:p>
-          <a:p>
-            <a:pPr lvl="1"/>
-            <a:r>
-              <a:rPr lang="en-US"/>
-              <a:t>Second level</a:t>
-            </a:r>
-          </a:p>
-          <a:p>
-            <a:pPr lvl="2"/>
-            <a:r>
-              <a:rPr lang="en-US"/>
-              <a:t>Third level</a:t>
-            </a:r>
-          </a:p>
-          <a:p>
-            <a:pPr lvl="3"/>
-            <a:r>
-              <a:rPr lang="en-US"/>
-              <a:t>Fourth level</a:t>
-            </a:r>
-          </a:p>
-          <a:p>
-            <a:pPr lvl="4"/>
-            <a:r>
-              <a:rPr lang="en-US"/>
-              <a:t>Fifth level</a:t>
-            </a:r>
-          </a:p>
-        </p:txBody>
-      </p:sp>
-      <p:sp>
-        <p:nvSpPr>
-          <p:cNvPr id="6" name="Footer Placeholder 5"/>
-          <p:cNvSpPr>
-            <a:spLocks noGrp="1"/>
-          </p:cNvSpPr>
-          <p:nvPr>
-            <p:ph type="ftr" sz="quarter" idx="4"/>
-          </p:nvPr>
-        </p:nvSpPr>
-        <p:spPr>
-          <a:xfrm>
-            <a:off x="0" y="8685213"/>
-            <a:ext cx="2971800" cy="458787"/>
-          </a:xfrm>
-          <a:prstGeom prst="rect">
-            <a:avLst/>
-          </a:prstGeom>
-        </p:spPr>
-        <p:txBody>
-          <a:bodyPr vert="horz" lIns="91440" tIns="45720" rIns="91440" bIns="45720" rtlCol="0" anchor="b"/>
-          <a:lstStyle>
-            <a:lvl1pPr algn="l">
-              <a:defRPr sz="1200"/>
-            </a:lvl1pPr>
-          </a:lstStyle>
-          <a:p>
-            <a:endParaRPr lang="en-US"/>
-          </a:p>
-        </p:txBody>
-      </p:sp>
-      <p:sp>
-        <p:nvSpPr>
-          <p:cNvPr id="7" name="Slide Number Placeholder 6"/>
-          <p:cNvSpPr>
-            <a:spLocks noGrp="1"/>
-          </p:cNvSpPr>
-          <p:nvPr>
-            <p:ph type="sldNum" sz="quarter" idx="5"/>
-          </p:nvPr>
-        </p:nvSpPr>
-        <p:spPr>
-          <a:xfrm>
-            <a:off x="3884613" y="8685213"/>
-            <a:ext cx="2971800" cy="458787"/>
-          </a:xfrm>
-          <a:prstGeom prst="rect">
-            <a:avLst/>
-          </a:prstGeom>
-        </p:spPr>
-        <p:txBody>
-          <a:bodyPr vert="horz" lIns="91440" tIns="45720" rIns="91440" bIns="45720" rtlCol="0" anchor="b"/>
-          <a:lstStyle>
-            <a:lvl1pPr algn="r">
-              <a:defRPr sz="1200"/>
-            </a:lvl1pPr>
-          </a:lstStyle>
-          <a:p>
-            <a:fld id="{CE5E9CC1-C706-0F49-92D6-E571CC5EEA8F}" type="slidenum">
-              <a:rPr lang="en-US"/>
-              <a:t>‹#›</a:t>
-            </a:fld>
-            <a:endParaRPr lang="en-US"/>
-          </a:p>
-        </p:txBody>
-      </p:sp>
     </p:spTree>
     <p:extLst>
       <p:ext uri="{BB962C8B-B14F-4D97-AF65-F5344CB8AC3E}">
-        <p14:creationId xmlns:p14="http://schemas.microsoft.com/office/powerpoint/2010/main" val="1024086991"/>
+        <p14:creationId xmlns:p14="http://schemas.microsoft.com/office/powerpoint/2010/main" val="267639306"/>
       </p:ext>
     </p:extLst>
   </p:cSld>
@@ -514,10 +295,6 @@
           <a:bodyPr/>
           <a:lstStyle/>
           <a:p>
-            <a:r>
-              <a:rPr lang="en-US" dirty="0"/>
-              <a:t/>
-            </a:r>
             <a:endParaRPr lang="en-US" dirty="0"/>
           </a:p>
         </p:txBody>
@@ -606,7 +383,6 @@
               <a:rPr lang="en-US" dirty="0"/>
               <a:t>Links seht ihr Prop Drilling – der User wird durch jede Ebene gereicht. Rechts Context – der Provider wrapped alles und Avatar greift direkt zu. Layout und Sidebar müssen nichts weiterreichen.</a:t>
             </a:r>
-            <a:endParaRPr lang="en-US" dirty="0"/>
           </a:p>
         </p:txBody>
       </p:sp>
@@ -694,7 +470,6 @@
               <a:rPr lang="en-US" dirty="0"/>
               <a:t>Aber Context hat auch Grenzen. Erstens: Jede Änderung am Context-Wert rendert ALLE Consumer neu. Zweitens: Für schnelle Updates wie Slider oder Drag and Drop ist es zu langsam. Drittens: Viele Contexts führen zu Provider Hell. Trotzdem perfekt für Sachen die sich selten ändern: Theme, Auth, Sprache.</a:t>
             </a:r>
-            <a:endParaRPr lang="en-US" dirty="0"/>
           </a:p>
         </p:txBody>
       </p:sp>
@@ -782,7 +557,6 @@
               <a:rPr lang="en-US" dirty="0"/>
               <a:t>Wenn Context nicht reicht, gibt es externe Libraries. Redux ist der Klassiker – mächtig aber viel Boilerplate. Redux Toolkit macht das besser. Zustand ist der moderne Trend – minimale API, kein Provider nötig, und trotzdem volle Kontrolle. Hier seht ihr wie einfach ein Zustand-Store aussieht.</a:t>
             </a:r>
-            <a:endParaRPr lang="en-US" dirty="0"/>
           </a:p>
         </p:txBody>
       </p:sp>
@@ -870,7 +644,6 @@
               <a:rPr lang="en-US" dirty="0"/>
               <a:t>Hier nochmal im Überblick: useState für einfache lokale Werte. useReducer wenn die Logik komplex wird. Context für globalen State der sich selten ändert. Redux für große Enterprise Apps. Zustand als moderner Standard. Faustregel: Starte einfach und skaliere bei Bedarf.</a:t>
             </a:r>
-            <a:endParaRPr lang="en-US" dirty="0"/>
           </a:p>
         </p:txBody>
       </p:sp>
@@ -958,7 +731,6 @@
               <a:rPr lang="en-US" dirty="0"/>
               <a:t>Das sind die 6 Takeaways. State Management muss nicht kompliziert sein – starte mit useState, erweitere schrittweise wenn nötig, und wähle das richtige Tool für den Job.</a:t>
             </a:r>
-            <a:endParaRPr lang="en-US" dirty="0"/>
           </a:p>
         </p:txBody>
       </p:sp>
@@ -1046,7 +818,6 @@
               <a:rPr lang="en-US" dirty="0"/>
               <a:t>Danke fürs Zuhören! Gerne Fragen.</a:t>
             </a:r>
-            <a:endParaRPr lang="en-US" dirty="0"/>
           </a:p>
         </p:txBody>
       </p:sp>
@@ -1134,7 +905,6 @@
               <a:rPr lang="en-US" dirty="0"/>
               <a:t>Hier ist der Überblick – wir starten mit dem Problem, gehen durch die React-eigenen Lösungen, und schauen uns am Ende kurz externe Libs an.</a:t>
             </a:r>
-            <a:endParaRPr lang="en-US" dirty="0"/>
           </a:p>
         </p:txBody>
       </p:sp>
@@ -1222,7 +992,6 @@
               <a:rPr lang="en-US" dirty="0"/>
               <a:t>State sind die Daten die sich ändern während die App läuft. Das kann alles sein – User-Input, API-Daten, ob ein Modal offen ist. Die Frage ist: Wie verwalten wir das, besonders wenn mehrere Komponenten den gleichen State brauchen?</a:t>
             </a:r>
-            <a:endParaRPr lang="en-US" dirty="0"/>
           </a:p>
         </p:txBody>
       </p:sp>
@@ -1310,7 +1079,6 @@
               <a:rPr lang="en-US" dirty="0"/>
               <a:t>Prop Drilling heißt: Wir reichen Props durch jede Ebene der Komponentenhierarchie. Layout und Sidebar brauchen den User gar nicht – sie geben ihn nur weiter. Bei 2-3 Ebenen geht das noch, aber bei einer großen App wird das schnell zum Problem.</a:t>
             </a:r>
-            <a:endParaRPr lang="en-US" dirty="0"/>
           </a:p>
         </p:txBody>
       </p:sp>
@@ -1398,7 +1166,6 @@
               <a:rPr lang="en-US" dirty="0"/>
               <a:t>Kurzer Recap: useState kennt ihr ja schon. Einfach, intuitiv, perfekt für lokalen State. Aber es hat Grenzen – wenn mehrere States zusammengehören oder global gebraucht werden.</a:t>
             </a:r>
-            <a:endParaRPr lang="en-US" dirty="0"/>
           </a:p>
         </p:txBody>
       </p:sp>
@@ -1486,7 +1253,6 @@
               <a:rPr lang="en-US" dirty="0"/>
               <a:t>Hier seht ihr das Problem konkret: Wir haben 3 States die zusammengehören – items, loading, error. Bei jedem Fetch müssen wir alle 3 manuell setzen. Das vergisst man leicht und es wird unübersichtlich.</a:t>
             </a:r>
-            <a:endParaRPr lang="en-US" dirty="0"/>
           </a:p>
         </p:txBody>
       </p:sp>
@@ -1574,7 +1340,6 @@
               <a:rPr lang="en-US" dirty="0"/>
               <a:t>useReducer löst genau das. Es hat 3 Teile: State ist ein Objekt mit allem Zustand. Action ist ein Zettel der sagt was passieren soll. Und der Reducer ist die Funktion mit den Regeln – er nimmt den alten State plus die Action und gibt den neuen State zurück.</a:t>
             </a:r>
-            <a:endParaRPr lang="en-US" dirty="0"/>
           </a:p>
         </p:txBody>
       </p:sp>
@@ -1662,7 +1427,6 @@
               <a:rPr lang="en-US" dirty="0"/>
               <a:t>So sieht das konkret aus. Der Reducer hat einen switch-case für jeden Action-Type. fetch_start setzt loading auf true und error auf null – in einem Schritt, keine Chance was zu vergessen. fetch_success setzt die Items und loading false. Alles konsistent.</a:t>
             </a:r>
-            <a:endParaRPr lang="en-US" dirty="0"/>
           </a:p>
         </p:txBody>
       </p:sp>
@@ -1750,7 +1514,6 @@
               <a:rPr lang="en-US" dirty="0"/>
               <a:t>Context API löst das Prop Drilling Problem. In 3 Schritten: Erst einen Context erstellen, dann den Provider um die App wrappen mit dem Wert, und dann kann jede Komponente egal wie tief verschachtelt mit useContext direkt auf den Wert zugreifen.</a:t>
             </a:r>
-            <a:endParaRPr lang="en-US" dirty="0"/>
           </a:p>
         </p:txBody>
       </p:sp>
@@ -1823,6 +1586,11 @@
 <file path=ppt/slideMasters/slideMaster1.xml><?xml version="1.0" encoding="utf-8"?>
 <p:sldMaster xmlns:a="http://schemas.openxmlformats.org/drawingml/2006/main" xmlns:r="http://schemas.openxmlformats.org/officeDocument/2006/relationships" xmlns:p="http://schemas.openxmlformats.org/presentationml/2006/main">
   <p:cSld>
+    <p:bg>
+      <p:bgRef idx="1001">
+        <a:schemeClr val="bg1"/>
+      </p:bgRef>
+    </p:bg>
     <p:spTree>
       <p:nvGrpSpPr>
         <p:cNvPr id="1" name=""/>
@@ -2105,6 +1873,7 @@
         <a:solidFill>
           <a:srgbClr val="0F1729"/>
         </a:solidFill>
+        <a:effectLst/>
       </p:bgPr>
     </p:bg>
     <p:spTree>
@@ -2142,6 +1911,13 @@
           </a:solidFill>
           <a:ln/>
         </p:spPr>
+        <p:txBody>
+          <a:bodyPr/>
+          <a:lstStyle/>
+          <a:p>
+            <a:endParaRPr lang="en-US"/>
+          </a:p>
+        </p:txBody>
       </p:sp>
       <p:sp>
         <p:nvSpPr>
@@ -2164,6 +1940,13 @@
           </a:solidFill>
           <a:ln/>
         </p:spPr>
+        <p:txBody>
+          <a:bodyPr/>
+          <a:lstStyle/>
+          <a:p>
+            <a:endParaRPr lang="en-US"/>
+          </a:p>
+        </p:txBody>
       </p:sp>
       <p:sp>
         <p:nvSpPr>
@@ -2186,7 +1969,7 @@
           <a:bodyPr wrap="square" lIns="0" tIns="0" rIns="0" bIns="0" rtlCol="0" anchor="ctr"/>
           <a:lstStyle/>
           <a:p>
-            <a:pPr indent="0" marL="0">
+            <a:pPr marL="0" indent="0">
               <a:buNone/>
             </a:pPr>
             <a:r>
@@ -2225,7 +2008,7 @@
           <a:bodyPr wrap="square" lIns="0" tIns="0" rIns="0" bIns="0" rtlCol="0" anchor="ctr"/>
           <a:lstStyle/>
           <a:p>
-            <a:pPr indent="0" marL="0">
+            <a:pPr marL="0" indent="0">
               <a:buNone/>
             </a:pPr>
             <a:r>
@@ -2262,6 +2045,13 @@
           </a:solidFill>
           <a:ln/>
         </p:spPr>
+        <p:txBody>
+          <a:bodyPr/>
+          <a:lstStyle/>
+          <a:p>
+            <a:endParaRPr lang="en-US"/>
+          </a:p>
+        </p:txBody>
       </p:sp>
       <p:sp>
         <p:nvSpPr>
@@ -2284,7 +2074,7 @@
           <a:bodyPr wrap="square" lIns="0" tIns="0" rIns="0" bIns="0" rtlCol="0" anchor="ctr"/>
           <a:lstStyle/>
           <a:p>
-            <a:pPr indent="0" marL="0">
+            <a:pPr marL="0" indent="0">
               <a:buNone/>
             </a:pPr>
             <a:r>
@@ -2304,14 +2094,14 @@
       </p:sp>
       <p:pic>
         <p:nvPicPr>
-          <p:cNvPr id="8" name="Image 0" descr="preencoded.png">    </p:cNvPr>
+          <p:cNvPr id="8" name="Image 0" descr="preencoded.png"/>
           <p:cNvPicPr>
             <a:picLocks noChangeAspect="1"/>
           </p:cNvPicPr>
           <p:nvPr/>
         </p:nvPicPr>
         <p:blipFill>
-          <a:blip r:embed="rId1"/>
+          <a:blip r:embed="rId3"/>
           <a:stretch>
             <a:fillRect/>
           </a:stretch>
@@ -2342,6 +2132,7 @@
         <a:solidFill>
           <a:srgbClr val="0F1729"/>
         </a:solidFill>
+        <a:effectLst/>
       </p:bgPr>
     </p:bg>
     <p:spTree>
@@ -2379,7 +2170,7 @@
           <a:bodyPr wrap="square" lIns="0" tIns="0" rIns="0" bIns="0" rtlCol="0" anchor="ctr"/>
           <a:lstStyle/>
           <a:p>
-            <a:pPr indent="0" marL="0">
+            <a:pPr marL="0" indent="0">
               <a:buNone/>
             </a:pPr>
             <a:r>
@@ -2416,6 +2207,13 @@
           </a:solidFill>
           <a:ln/>
         </p:spPr>
+        <p:txBody>
+          <a:bodyPr/>
+          <a:lstStyle/>
+          <a:p>
+            <a:endParaRPr lang="en-US"/>
+          </a:p>
+        </p:txBody>
       </p:sp>
       <p:sp>
         <p:nvSpPr>
@@ -2438,7 +2236,7 @@
           <a:bodyPr wrap="square" lIns="0" tIns="0" rIns="0" bIns="0" rtlCol="0" anchor="ctr"/>
           <a:lstStyle/>
           <a:p>
-            <a:pPr algn="ctr" indent="0" marL="0">
+            <a:pPr marL="0" indent="0" algn="ctr">
               <a:buNone/>
             </a:pPr>
             <a:r>
@@ -2477,6 +2275,13 @@
           </a:solidFill>
           <a:ln/>
         </p:spPr>
+        <p:txBody>
+          <a:bodyPr/>
+          <a:lstStyle/>
+          <a:p>
+            <a:endParaRPr lang="en-US"/>
+          </a:p>
+        </p:txBody>
       </p:sp>
       <p:sp>
         <p:nvSpPr>
@@ -2499,7 +2304,7 @@
           <a:bodyPr wrap="square" lIns="0" tIns="0" rIns="0" bIns="0" rtlCol="0" anchor="ctr"/>
           <a:lstStyle/>
           <a:p>
-            <a:pPr algn="ctr" indent="0" marL="0">
+            <a:pPr marL="0" indent="0" algn="ctr">
               <a:buNone/>
             </a:pPr>
             <a:r>
@@ -2539,6 +2344,13 @@
             <a:prstDash val="solid"/>
           </a:ln>
         </p:spPr>
+        <p:txBody>
+          <a:bodyPr/>
+          <a:lstStyle/>
+          <a:p>
+            <a:endParaRPr lang="en-US"/>
+          </a:p>
+        </p:txBody>
       </p:sp>
       <p:sp>
         <p:nvSpPr>
@@ -2561,6 +2373,13 @@
           </a:solidFill>
           <a:ln/>
         </p:spPr>
+        <p:txBody>
+          <a:bodyPr/>
+          <a:lstStyle/>
+          <a:p>
+            <a:endParaRPr lang="en-US"/>
+          </a:p>
+        </p:txBody>
       </p:sp>
       <p:sp>
         <p:nvSpPr>
@@ -2583,7 +2402,7 @@
           <a:bodyPr wrap="square" lIns="0" tIns="0" rIns="0" bIns="0" rtlCol="0" anchor="ctr"/>
           <a:lstStyle/>
           <a:p>
-            <a:pPr algn="ctr" indent="0" marL="0">
+            <a:pPr marL="0" indent="0" algn="ctr">
               <a:buNone/>
             </a:pPr>
             <a:r>
@@ -2623,6 +2442,13 @@
             <a:prstDash val="solid"/>
           </a:ln>
         </p:spPr>
+        <p:txBody>
+          <a:bodyPr/>
+          <a:lstStyle/>
+          <a:p>
+            <a:endParaRPr lang="en-US"/>
+          </a:p>
+        </p:txBody>
       </p:sp>
       <p:sp>
         <p:nvSpPr>
@@ -2645,6 +2471,13 @@
           </a:solidFill>
           <a:ln/>
         </p:spPr>
+        <p:txBody>
+          <a:bodyPr/>
+          <a:lstStyle/>
+          <a:p>
+            <a:endParaRPr lang="en-US"/>
+          </a:p>
+        </p:txBody>
       </p:sp>
       <p:sp>
         <p:nvSpPr>
@@ -2667,7 +2500,7 @@
           <a:bodyPr wrap="square" lIns="0" tIns="0" rIns="0" bIns="0" rtlCol="0" anchor="ctr"/>
           <a:lstStyle/>
           <a:p>
-            <a:pPr algn="ctr" indent="0" marL="0">
+            <a:pPr marL="0" indent="0" algn="ctr">
               <a:buNone/>
             </a:pPr>
             <a:r>
@@ -2707,6 +2540,13 @@
             <a:prstDash val="solid"/>
           </a:ln>
         </p:spPr>
+        <p:txBody>
+          <a:bodyPr/>
+          <a:lstStyle/>
+          <a:p>
+            <a:endParaRPr lang="en-US"/>
+          </a:p>
+        </p:txBody>
       </p:sp>
       <p:sp>
         <p:nvSpPr>
@@ -2729,6 +2569,13 @@
           </a:solidFill>
           <a:ln/>
         </p:spPr>
+        <p:txBody>
+          <a:bodyPr/>
+          <a:lstStyle/>
+          <a:p>
+            <a:endParaRPr lang="en-US"/>
+          </a:p>
+        </p:txBody>
       </p:sp>
       <p:sp>
         <p:nvSpPr>
@@ -2751,7 +2598,7 @@
           <a:bodyPr wrap="square" lIns="0" tIns="0" rIns="0" bIns="0" rtlCol="0" anchor="ctr"/>
           <a:lstStyle/>
           <a:p>
-            <a:pPr algn="ctr" indent="0" marL="0">
+            <a:pPr marL="0" indent="0" algn="ctr">
               <a:buNone/>
             </a:pPr>
             <a:r>
@@ -2790,7 +2637,7 @@
           <a:bodyPr wrap="square" lIns="0" tIns="0" rIns="0" bIns="0" rtlCol="0" anchor="ctr"/>
           <a:lstStyle/>
           <a:p>
-            <a:pPr algn="ctr" indent="0" marL="0">
+            <a:pPr marL="0" indent="0" algn="ctr">
               <a:buNone/>
             </a:pPr>
             <a:r>
@@ -2829,6 +2676,13 @@
           </a:solidFill>
           <a:ln/>
         </p:spPr>
+        <p:txBody>
+          <a:bodyPr/>
+          <a:lstStyle/>
+          <a:p>
+            <a:endParaRPr lang="en-US"/>
+          </a:p>
+        </p:txBody>
       </p:sp>
       <p:sp>
         <p:nvSpPr>
@@ -2851,7 +2705,7 @@
           <a:bodyPr wrap="square" lIns="0" tIns="0" rIns="0" bIns="0" rtlCol="0" anchor="ctr"/>
           <a:lstStyle/>
           <a:p>
-            <a:pPr algn="ctr" indent="0" marL="0">
+            <a:pPr marL="0" indent="0" algn="ctr">
               <a:buNone/>
             </a:pPr>
             <a:r>
@@ -2890,6 +2744,13 @@
           </a:solidFill>
           <a:ln/>
         </p:spPr>
+        <p:txBody>
+          <a:bodyPr/>
+          <a:lstStyle/>
+          <a:p>
+            <a:endParaRPr lang="en-US"/>
+          </a:p>
+        </p:txBody>
       </p:sp>
       <p:sp>
         <p:nvSpPr>
@@ -2912,7 +2773,7 @@
           <a:bodyPr wrap="square" lIns="0" tIns="0" rIns="0" bIns="0" rtlCol="0" anchor="ctr"/>
           <a:lstStyle/>
           <a:p>
-            <a:pPr algn="ctr" indent="0" marL="0">
+            <a:pPr marL="0" indent="0" algn="ctr">
               <a:buNone/>
             </a:pPr>
             <a:r>
@@ -2951,6 +2812,13 @@
           </a:solidFill>
           <a:ln/>
         </p:spPr>
+        <p:txBody>
+          <a:bodyPr/>
+          <a:lstStyle/>
+          <a:p>
+            <a:endParaRPr lang="en-US"/>
+          </a:p>
+        </p:txBody>
       </p:sp>
       <p:sp>
         <p:nvSpPr>
@@ -2973,7 +2841,7 @@
           <a:bodyPr wrap="square" lIns="0" tIns="0" rIns="0" bIns="0" rtlCol="0" anchor="ctr"/>
           <a:lstStyle/>
           <a:p>
-            <a:pPr algn="ctr" indent="0" marL="0">
+            <a:pPr marL="0" indent="0" algn="ctr">
               <a:buNone/>
             </a:pPr>
             <a:r>
@@ -3012,6 +2880,13 @@
           </a:solidFill>
           <a:ln/>
         </p:spPr>
+        <p:txBody>
+          <a:bodyPr/>
+          <a:lstStyle/>
+          <a:p>
+            <a:endParaRPr lang="en-US"/>
+          </a:p>
+        </p:txBody>
       </p:sp>
       <p:sp>
         <p:nvSpPr>
@@ -3034,7 +2909,7 @@
           <a:bodyPr wrap="square" lIns="0" tIns="0" rIns="0" bIns="0" rtlCol="0" anchor="ctr"/>
           <a:lstStyle/>
           <a:p>
-            <a:pPr algn="ctr" indent="0" marL="0">
+            <a:pPr marL="0" indent="0" algn="ctr">
               <a:buNone/>
             </a:pPr>
             <a:r>
@@ -3073,6 +2948,13 @@
           </a:solidFill>
           <a:ln/>
         </p:spPr>
+        <p:txBody>
+          <a:bodyPr/>
+          <a:lstStyle/>
+          <a:p>
+            <a:endParaRPr lang="en-US"/>
+          </a:p>
+        </p:txBody>
       </p:sp>
       <p:sp>
         <p:nvSpPr>
@@ -3095,7 +2977,7 @@
           <a:bodyPr wrap="square" lIns="0" tIns="0" rIns="0" bIns="0" rtlCol="0" anchor="ctr"/>
           <a:lstStyle/>
           <a:p>
-            <a:pPr algn="ctr" indent="0" marL="0">
+            <a:pPr marL="0" indent="0" algn="ctr">
               <a:buNone/>
             </a:pPr>
             <a:r>
@@ -3134,7 +3016,7 @@
           <a:bodyPr wrap="square" lIns="0" tIns="0" rIns="0" bIns="0" rtlCol="0" anchor="ctr"/>
           <a:lstStyle/>
           <a:p>
-            <a:pPr indent="0" marL="0">
+            <a:pPr marL="0" indent="0">
               <a:buNone/>
             </a:pPr>
             <a:r>
@@ -3168,6 +3050,7 @@
         <a:solidFill>
           <a:srgbClr val="0F1729"/>
         </a:solidFill>
+        <a:effectLst/>
       </p:bgPr>
     </p:bg>
     <p:spTree>
@@ -3205,7 +3088,7 @@
           <a:bodyPr wrap="square" lIns="0" tIns="0" rIns="0" bIns="0" rtlCol="0" anchor="ctr"/>
           <a:lstStyle/>
           <a:p>
-            <a:pPr indent="0" marL="0">
+            <a:pPr marL="0" indent="0">
               <a:buNone/>
             </a:pPr>
             <a:r>
@@ -3242,6 +3125,13 @@
           </a:solidFill>
           <a:ln/>
         </p:spPr>
+        <p:txBody>
+          <a:bodyPr/>
+          <a:lstStyle/>
+          <a:p>
+            <a:endParaRPr lang="en-US"/>
+          </a:p>
+        </p:txBody>
       </p:sp>
       <p:sp>
         <p:nvSpPr>
@@ -3264,6 +3154,13 @@
           </a:solidFill>
           <a:ln/>
         </p:spPr>
+        <p:txBody>
+          <a:bodyPr/>
+          <a:lstStyle/>
+          <a:p>
+            <a:endParaRPr lang="en-US"/>
+          </a:p>
+        </p:txBody>
       </p:sp>
       <p:sp>
         <p:nvSpPr>
@@ -3286,7 +3183,7 @@
           <a:bodyPr wrap="square" lIns="0" tIns="0" rIns="0" bIns="0" rtlCol="0" anchor="ctr"/>
           <a:lstStyle/>
           <a:p>
-            <a:pPr indent="0" marL="0">
+            <a:pPr marL="0" indent="0">
               <a:buNone/>
             </a:pPr>
             <a:r>
@@ -3325,7 +3222,7 @@
           <a:bodyPr wrap="square" lIns="0" tIns="0" rIns="0" bIns="0" rtlCol="0" anchor="ctr"/>
           <a:lstStyle/>
           <a:p>
-            <a:pPr indent="0" marL="0">
+            <a:pPr marL="0" indent="0">
               <a:buNone/>
             </a:pPr>
             <a:r>
@@ -3364,6 +3261,13 @@
           </a:solidFill>
           <a:ln/>
         </p:spPr>
+        <p:txBody>
+          <a:bodyPr/>
+          <a:lstStyle/>
+          <a:p>
+            <a:endParaRPr lang="en-US"/>
+          </a:p>
+        </p:txBody>
       </p:sp>
       <p:sp>
         <p:nvSpPr>
@@ -3386,7 +3290,7 @@
           <a:bodyPr wrap="square" lIns="0" tIns="0" rIns="0" bIns="0" rtlCol="0" anchor="ctr"/>
           <a:lstStyle/>
           <a:p>
-            <a:pPr indent="0" marL="0">
+            <a:pPr marL="0" indent="0">
               <a:buNone/>
             </a:pPr>
             <a:r>
@@ -3425,7 +3329,7 @@
           <a:bodyPr wrap="square" lIns="0" tIns="0" rIns="0" bIns="0" rtlCol="0" anchor="ctr"/>
           <a:lstStyle/>
           <a:p>
-            <a:pPr indent="0" marL="0">
+            <a:pPr marL="0" indent="0">
               <a:buNone/>
             </a:pPr>
             <a:r>
@@ -3464,6 +3368,13 @@
           </a:solidFill>
           <a:ln/>
         </p:spPr>
+        <p:txBody>
+          <a:bodyPr/>
+          <a:lstStyle/>
+          <a:p>
+            <a:endParaRPr lang="en-US"/>
+          </a:p>
+        </p:txBody>
       </p:sp>
       <p:sp>
         <p:nvSpPr>
@@ -3486,7 +3397,7 @@
           <a:bodyPr wrap="square" lIns="0" tIns="0" rIns="0" bIns="0" rtlCol="0" anchor="ctr"/>
           <a:lstStyle/>
           <a:p>
-            <a:pPr indent="0" marL="0">
+            <a:pPr marL="0" indent="0">
               <a:buNone/>
             </a:pPr>
             <a:r>
@@ -3525,7 +3436,7 @@
           <a:bodyPr wrap="square" lIns="0" tIns="0" rIns="0" bIns="0" rtlCol="0" anchor="ctr"/>
           <a:lstStyle/>
           <a:p>
-            <a:pPr indent="0" marL="0">
+            <a:pPr marL="0" indent="0">
               <a:buNone/>
             </a:pPr>
             <a:r>
@@ -3564,7 +3475,7 @@
           <a:bodyPr wrap="square" lIns="0" tIns="0" rIns="0" bIns="0" rtlCol="0" anchor="ctr"/>
           <a:lstStyle/>
           <a:p>
-            <a:pPr indent="0" marL="0">
+            <a:pPr marL="0" indent="0">
               <a:buNone/>
             </a:pPr>
             <a:r>
@@ -3598,6 +3509,7 @@
         <a:solidFill>
           <a:srgbClr val="0F1729"/>
         </a:solidFill>
+        <a:effectLst/>
       </p:bgPr>
     </p:bg>
     <p:spTree>
@@ -3635,7 +3547,7 @@
           <a:bodyPr wrap="square" lIns="0" tIns="0" rIns="0" bIns="0" rtlCol="0" anchor="ctr"/>
           <a:lstStyle/>
           <a:p>
-            <a:pPr indent="0" marL="0">
+            <a:pPr marL="0" indent="0">
               <a:buNone/>
             </a:pPr>
             <a:r>
@@ -3672,6 +3584,13 @@
           </a:solidFill>
           <a:ln/>
         </p:spPr>
+        <p:txBody>
+          <a:bodyPr/>
+          <a:lstStyle/>
+          <a:p>
+            <a:endParaRPr lang="en-US"/>
+          </a:p>
+        </p:txBody>
       </p:sp>
       <p:sp>
         <p:nvSpPr>
@@ -3694,6 +3613,13 @@
           </a:solidFill>
           <a:ln/>
         </p:spPr>
+        <p:txBody>
+          <a:bodyPr/>
+          <a:lstStyle/>
+          <a:p>
+            <a:endParaRPr lang="en-US"/>
+          </a:p>
+        </p:txBody>
       </p:sp>
       <p:sp>
         <p:nvSpPr>
@@ -3716,7 +3642,7 @@
           <a:bodyPr wrap="square" lIns="0" tIns="0" rIns="0" bIns="0" rtlCol="0" anchor="ctr"/>
           <a:lstStyle/>
           <a:p>
-            <a:pPr indent="0" marL="0">
+            <a:pPr marL="0" indent="0">
               <a:buNone/>
             </a:pPr>
             <a:r>
@@ -3861,6 +3787,13 @@
           </a:solidFill>
           <a:ln/>
         </p:spPr>
+        <p:txBody>
+          <a:bodyPr/>
+          <a:lstStyle/>
+          <a:p>
+            <a:endParaRPr lang="en-US"/>
+          </a:p>
+        </p:txBody>
       </p:sp>
       <p:sp>
         <p:nvSpPr>
@@ -3883,7 +3816,7 @@
           <a:bodyPr wrap="square" lIns="0" tIns="0" rIns="0" bIns="0" rtlCol="0" anchor="ctr"/>
           <a:lstStyle/>
           <a:p>
-            <a:pPr indent="0" marL="0">
+            <a:pPr marL="0" indent="0">
               <a:buNone/>
             </a:pPr>
             <a:r>
@@ -4028,6 +3961,13 @@
           </a:solidFill>
           <a:ln/>
         </p:spPr>
+        <p:txBody>
+          <a:bodyPr/>
+          <a:lstStyle/>
+          <a:p>
+            <a:endParaRPr lang="en-US"/>
+          </a:p>
+        </p:txBody>
       </p:sp>
       <p:sp>
         <p:nvSpPr>
@@ -4050,7 +3990,7 @@
           <a:bodyPr wrap="square" rtlCol="0" anchor="t"/>
           <a:lstStyle/>
           <a:p>
-            <a:pPr indent="0" marL="0">
+            <a:pPr marL="0" indent="0">
               <a:buNone/>
             </a:pPr>
             <a:r>
@@ -4067,7 +4007,7 @@
             <a:endParaRPr lang="en-US" sz="1200" dirty="0"/>
           </a:p>
           <a:p>
-            <a:pPr indent="0" marL="0">
+            <a:pPr marL="0" indent="0">
               <a:buNone/>
             </a:pPr>
             <a:r>
@@ -4084,7 +4024,7 @@
             <a:endParaRPr lang="en-US" sz="1200" dirty="0"/>
           </a:p>
           <a:p>
-            <a:pPr indent="0" marL="0">
+            <a:pPr marL="0" indent="0">
               <a:buNone/>
             </a:pPr>
             <a:r>
@@ -4101,7 +4041,7 @@
             <a:endParaRPr lang="en-US" sz="1200" dirty="0"/>
           </a:p>
           <a:p>
-            <a:pPr indent="0" marL="0">
+            <a:pPr marL="0" indent="0">
               <a:buNone/>
             </a:pPr>
             <a:r>
@@ -4118,7 +4058,7 @@
             <a:endParaRPr lang="en-US" sz="1200" dirty="0"/>
           </a:p>
           <a:p>
-            <a:pPr indent="0" marL="0">
+            <a:pPr marL="0" indent="0">
               <a:buNone/>
             </a:pPr>
             <a:r>
@@ -4152,6 +4092,7 @@
         <a:solidFill>
           <a:srgbClr val="0F1729"/>
         </a:solidFill>
+        <a:effectLst/>
       </p:bgPr>
     </p:bg>
     <p:spTree>
@@ -4189,7 +4130,7 @@
           <a:bodyPr wrap="square" lIns="0" tIns="0" rIns="0" bIns="0" rtlCol="0" anchor="ctr"/>
           <a:lstStyle/>
           <a:p>
-            <a:pPr indent="0" marL="0">
+            <a:pPr marL="0" indent="0">
               <a:buNone/>
             </a:pPr>
             <a:r>
@@ -4226,6 +4167,13 @@
           </a:solidFill>
           <a:ln/>
         </p:spPr>
+        <p:txBody>
+          <a:bodyPr/>
+          <a:lstStyle/>
+          <a:p>
+            <a:endParaRPr lang="en-US"/>
+          </a:p>
+        </p:txBody>
       </p:sp>
       <p:graphicFrame>
         <p:nvGraphicFramePr>
@@ -4250,10 +4198,34 @@
             <a:tbl>
               <a:tblPr/>
               <a:tblGrid>
-                <a:gridCol w="1645920"/>
-                <a:gridCol w="1645920"/>
-                <a:gridCol w="1371600"/>
-                <a:gridCol w="3017520"/>
+                <a:gridCol w="1645920">
+                  <a:extLst>
+                    <a:ext uri="{9D8B030D-6E8A-4147-A177-3AD203B41FA5}">
+                      <a16:colId xmlns:a16="http://schemas.microsoft.com/office/drawing/2014/main" val="20000"/>
+                    </a:ext>
+                  </a:extLst>
+                </a:gridCol>
+                <a:gridCol w="1645920">
+                  <a:extLst>
+                    <a:ext uri="{9D8B030D-6E8A-4147-A177-3AD203B41FA5}">
+                      <a16:colId xmlns:a16="http://schemas.microsoft.com/office/drawing/2014/main" val="20001"/>
+                    </a:ext>
+                  </a:extLst>
+                </a:gridCol>
+                <a:gridCol w="1371600">
+                  <a:extLst>
+                    <a:ext uri="{9D8B030D-6E8A-4147-A177-3AD203B41FA5}">
+                      <a16:colId xmlns:a16="http://schemas.microsoft.com/office/drawing/2014/main" val="20002"/>
+                    </a:ext>
+                  </a:extLst>
+                </a:gridCol>
+                <a:gridCol w="3017520">
+                  <a:extLst>
+                    <a:ext uri="{9D8B030D-6E8A-4147-A177-3AD203B41FA5}">
+                      <a16:colId xmlns:a16="http://schemas.microsoft.com/office/drawing/2014/main" val="20003"/>
+                    </a:ext>
+                  </a:extLst>
+                </a:gridCol>
               </a:tblGrid>
               <a:tr h="457200">
                 <a:tc>
@@ -4261,7 +4233,7 @@
                     <a:bodyPr/>
                     <a:lstStyle/>
                     <a:p>
-                      <a:pPr indent="0" marL="0">
+                      <a:pPr marL="0" indent="0">
                         <a:buNone/>
                       </a:pPr>
                       <a:endParaRPr lang="en-US" sz="1300" dirty="0">
@@ -4271,7 +4243,7 @@
                       </a:endParaRPr>
                     </a:p>
                   </a:txBody>
-                  <a:tcPr marL="91440" marR="91440" marT="45720" marB="45720">
+                  <a:tcPr>
                     <a:lnL w="6350" cap="flat" cmpd="sng" algn="ctr">
                       <a:solidFill>
                         <a:srgbClr val="475569"/>
@@ -4318,7 +4290,7 @@
                     <a:bodyPr/>
                     <a:lstStyle/>
                     <a:p>
-                      <a:pPr algn="ctr" indent="0" marL="0">
+                      <a:pPr marL="0" indent="0" algn="ctr">
                         <a:buNone/>
                       </a:pPr>
                       <a:r>
@@ -4339,7 +4311,7 @@
                       </a:endParaRPr>
                     </a:p>
                   </a:txBody>
-                  <a:tcPr marL="91440" marR="91440" marT="45720" marB="45720">
+                  <a:tcPr>
                     <a:lnL w="6350" cap="flat" cmpd="sng" algn="ctr">
                       <a:solidFill>
                         <a:srgbClr val="475569"/>
@@ -4386,7 +4358,7 @@
                     <a:bodyPr/>
                     <a:lstStyle/>
                     <a:p>
-                      <a:pPr algn="ctr" indent="0" marL="0">
+                      <a:pPr marL="0" indent="0" algn="ctr">
                         <a:buNone/>
                       </a:pPr>
                       <a:r>
@@ -4407,7 +4379,7 @@
                       </a:endParaRPr>
                     </a:p>
                   </a:txBody>
-                  <a:tcPr marL="91440" marR="91440" marT="45720" marB="45720">
+                  <a:tcPr>
                     <a:lnL w="6350" cap="flat" cmpd="sng" algn="ctr">
                       <a:solidFill>
                         <a:srgbClr val="475569"/>
@@ -4454,7 +4426,7 @@
                     <a:bodyPr/>
                     <a:lstStyle/>
                     <a:p>
-                      <a:pPr algn="ctr" indent="0" marL="0">
+                      <a:pPr marL="0" indent="0" algn="ctr">
                         <a:buNone/>
                       </a:pPr>
                       <a:r>
@@ -4475,7 +4447,7 @@
                       </a:endParaRPr>
                     </a:p>
                   </a:txBody>
-                  <a:tcPr marL="91440" marR="91440" marT="45720" marB="45720">
+                  <a:tcPr>
                     <a:lnL w="6350" cap="flat" cmpd="sng" algn="ctr">
                       <a:solidFill>
                         <a:srgbClr val="475569"/>
@@ -4517,6 +4489,11 @@
                     </a:solidFill>
                   </a:tcPr>
                 </a:tc>
+                <a:extLst>
+                  <a:ext uri="{0D108BD9-81ED-4DB2-BD59-A6C34878D82A}">
+                    <a16:rowId xmlns:a16="http://schemas.microsoft.com/office/drawing/2014/main" val="10000"/>
+                  </a:ext>
+                </a:extLst>
               </a:tr>
               <a:tr h="457200">
                 <a:tc>
@@ -4524,7 +4501,7 @@
                     <a:bodyPr/>
                     <a:lstStyle/>
                     <a:p>
-                      <a:pPr indent="0" marL="0">
+                      <a:pPr marL="0" indent="0">
                         <a:buNone/>
                       </a:pPr>
                       <a:r>
@@ -4545,7 +4522,7 @@
                       </a:endParaRPr>
                     </a:p>
                   </a:txBody>
-                  <a:tcPr marL="91440" marR="91440" marT="45720" marB="45720">
+                  <a:tcPr>
                     <a:lnL w="6350" cap="flat" cmpd="sng" algn="ctr">
                       <a:solidFill>
                         <a:srgbClr val="475569"/>
@@ -4592,7 +4569,7 @@
                     <a:bodyPr/>
                     <a:lstStyle/>
                     <a:p>
-                      <a:pPr algn="ctr" indent="0" marL="0">
+                      <a:pPr marL="0" indent="0" algn="ctr">
                         <a:buNone/>
                       </a:pPr>
                       <a:r>
@@ -4613,7 +4590,7 @@
                       </a:endParaRPr>
                     </a:p>
                   </a:txBody>
-                  <a:tcPr marL="91440" marR="91440" marT="45720" marB="45720">
+                  <a:tcPr>
                     <a:lnL w="6350" cap="flat" cmpd="sng" algn="ctr">
                       <a:solidFill>
                         <a:srgbClr val="475569"/>
@@ -4660,7 +4637,7 @@
                     <a:bodyPr/>
                     <a:lstStyle/>
                     <a:p>
-                      <a:pPr algn="ctr" indent="0" marL="0">
+                      <a:pPr marL="0" indent="0" algn="ctr">
                         <a:buNone/>
                       </a:pPr>
                       <a:r>
@@ -4681,7 +4658,7 @@
                       </a:endParaRPr>
                     </a:p>
                   </a:txBody>
-                  <a:tcPr marL="91440" marR="91440" marT="45720" marB="45720">
+                  <a:tcPr>
                     <a:lnL w="6350" cap="flat" cmpd="sng" algn="ctr">
                       <a:solidFill>
                         <a:srgbClr val="475569"/>
@@ -4728,7 +4705,7 @@
                     <a:bodyPr/>
                     <a:lstStyle/>
                     <a:p>
-                      <a:pPr algn="ctr" indent="0" marL="0">
+                      <a:pPr marL="0" indent="0" algn="ctr">
                         <a:buNone/>
                       </a:pPr>
                       <a:r>
@@ -4749,7 +4726,7 @@
                       </a:endParaRPr>
                     </a:p>
                   </a:txBody>
-                  <a:tcPr marL="91440" marR="91440" marT="45720" marB="45720">
+                  <a:tcPr>
                     <a:lnL w="6350" cap="flat" cmpd="sng" algn="ctr">
                       <a:solidFill>
                         <a:srgbClr val="475569"/>
@@ -4791,6 +4768,11 @@
                     </a:solidFill>
                   </a:tcPr>
                 </a:tc>
+                <a:extLst>
+                  <a:ext uri="{0D108BD9-81ED-4DB2-BD59-A6C34878D82A}">
+                    <a16:rowId xmlns:a16="http://schemas.microsoft.com/office/drawing/2014/main" val="10001"/>
+                  </a:ext>
+                </a:extLst>
               </a:tr>
               <a:tr h="457200">
                 <a:tc>
@@ -4798,7 +4780,7 @@
                     <a:bodyPr/>
                     <a:lstStyle/>
                     <a:p>
-                      <a:pPr indent="0" marL="0">
+                      <a:pPr marL="0" indent="0">
                         <a:buNone/>
                       </a:pPr>
                       <a:r>
@@ -4819,7 +4801,7 @@
                       </a:endParaRPr>
                     </a:p>
                   </a:txBody>
-                  <a:tcPr marL="91440" marR="91440" marT="45720" marB="45720">
+                  <a:tcPr>
                     <a:lnL w="6350" cap="flat" cmpd="sng" algn="ctr">
                       <a:solidFill>
                         <a:srgbClr val="475569"/>
@@ -4866,7 +4848,7 @@
                     <a:bodyPr/>
                     <a:lstStyle/>
                     <a:p>
-                      <a:pPr algn="ctr" indent="0" marL="0">
+                      <a:pPr marL="0" indent="0" algn="ctr">
                         <a:buNone/>
                       </a:pPr>
                       <a:r>
@@ -4887,7 +4869,7 @@
                       </a:endParaRPr>
                     </a:p>
                   </a:txBody>
-                  <a:tcPr marL="91440" marR="91440" marT="45720" marB="45720">
+                  <a:tcPr>
                     <a:lnL w="6350" cap="flat" cmpd="sng" algn="ctr">
                       <a:solidFill>
                         <a:srgbClr val="475569"/>
@@ -4934,7 +4916,7 @@
                     <a:bodyPr/>
                     <a:lstStyle/>
                     <a:p>
-                      <a:pPr algn="ctr" indent="0" marL="0">
+                      <a:pPr marL="0" indent="0" algn="ctr">
                         <a:buNone/>
                       </a:pPr>
                       <a:r>
@@ -4955,7 +4937,7 @@
                       </a:endParaRPr>
                     </a:p>
                   </a:txBody>
-                  <a:tcPr marL="91440" marR="91440" marT="45720" marB="45720">
+                  <a:tcPr>
                     <a:lnL w="6350" cap="flat" cmpd="sng" algn="ctr">
                       <a:solidFill>
                         <a:srgbClr val="475569"/>
@@ -5002,7 +4984,7 @@
                     <a:bodyPr/>
                     <a:lstStyle/>
                     <a:p>
-                      <a:pPr algn="ctr" indent="0" marL="0">
+                      <a:pPr marL="0" indent="0" algn="ctr">
                         <a:buNone/>
                       </a:pPr>
                       <a:r>
@@ -5023,7 +5005,7 @@
                       </a:endParaRPr>
                     </a:p>
                   </a:txBody>
-                  <a:tcPr marL="91440" marR="91440" marT="45720" marB="45720">
+                  <a:tcPr>
                     <a:lnL w="6350" cap="flat" cmpd="sng" algn="ctr">
                       <a:solidFill>
                         <a:srgbClr val="475569"/>
@@ -5065,6 +5047,11 @@
                     </a:solidFill>
                   </a:tcPr>
                 </a:tc>
+                <a:extLst>
+                  <a:ext uri="{0D108BD9-81ED-4DB2-BD59-A6C34878D82A}">
+                    <a16:rowId xmlns:a16="http://schemas.microsoft.com/office/drawing/2014/main" val="10002"/>
+                  </a:ext>
+                </a:extLst>
               </a:tr>
               <a:tr h="457200">
                 <a:tc>
@@ -5072,7 +5059,7 @@
                     <a:bodyPr/>
                     <a:lstStyle/>
                     <a:p>
-                      <a:pPr indent="0" marL="0">
+                      <a:pPr marL="0" indent="0">
                         <a:buNone/>
                       </a:pPr>
                       <a:r>
@@ -5093,7 +5080,7 @@
                       </a:endParaRPr>
                     </a:p>
                   </a:txBody>
-                  <a:tcPr marL="91440" marR="91440" marT="45720" marB="45720">
+                  <a:tcPr>
                     <a:lnL w="6350" cap="flat" cmpd="sng" algn="ctr">
                       <a:solidFill>
                         <a:srgbClr val="475569"/>
@@ -5140,7 +5127,7 @@
                     <a:bodyPr/>
                     <a:lstStyle/>
                     <a:p>
-                      <a:pPr algn="ctr" indent="0" marL="0">
+                      <a:pPr marL="0" indent="0" algn="ctr">
                         <a:buNone/>
                       </a:pPr>
                       <a:r>
@@ -5161,7 +5148,7 @@
                       </a:endParaRPr>
                     </a:p>
                   </a:txBody>
-                  <a:tcPr marL="91440" marR="91440" marT="45720" marB="45720">
+                  <a:tcPr>
                     <a:lnL w="6350" cap="flat" cmpd="sng" algn="ctr">
                       <a:solidFill>
                         <a:srgbClr val="475569"/>
@@ -5208,7 +5195,7 @@
                     <a:bodyPr/>
                     <a:lstStyle/>
                     <a:p>
-                      <a:pPr algn="ctr" indent="0" marL="0">
+                      <a:pPr marL="0" indent="0" algn="ctr">
                         <a:buNone/>
                       </a:pPr>
                       <a:r>
@@ -5229,7 +5216,7 @@
                       </a:endParaRPr>
                     </a:p>
                   </a:txBody>
-                  <a:tcPr marL="91440" marR="91440" marT="45720" marB="45720">
+                  <a:tcPr>
                     <a:lnL w="6350" cap="flat" cmpd="sng" algn="ctr">
                       <a:solidFill>
                         <a:srgbClr val="475569"/>
@@ -5276,7 +5263,7 @@
                     <a:bodyPr/>
                     <a:lstStyle/>
                     <a:p>
-                      <a:pPr algn="ctr" indent="0" marL="0">
+                      <a:pPr marL="0" indent="0" algn="ctr">
                         <a:buNone/>
                       </a:pPr>
                       <a:r>
@@ -5297,7 +5284,7 @@
                       </a:endParaRPr>
                     </a:p>
                   </a:txBody>
-                  <a:tcPr marL="91440" marR="91440" marT="45720" marB="45720">
+                  <a:tcPr>
                     <a:lnL w="6350" cap="flat" cmpd="sng" algn="ctr">
                       <a:solidFill>
                         <a:srgbClr val="475569"/>
@@ -5339,6 +5326,11 @@
                     </a:solidFill>
                   </a:tcPr>
                 </a:tc>
+                <a:extLst>
+                  <a:ext uri="{0D108BD9-81ED-4DB2-BD59-A6C34878D82A}">
+                    <a16:rowId xmlns:a16="http://schemas.microsoft.com/office/drawing/2014/main" val="10003"/>
+                  </a:ext>
+                </a:extLst>
               </a:tr>
               <a:tr h="457200">
                 <a:tc>
@@ -5346,7 +5338,7 @@
                     <a:bodyPr/>
                     <a:lstStyle/>
                     <a:p>
-                      <a:pPr indent="0" marL="0">
+                      <a:pPr marL="0" indent="0">
                         <a:buNone/>
                       </a:pPr>
                       <a:r>
@@ -5367,7 +5359,7 @@
                       </a:endParaRPr>
                     </a:p>
                   </a:txBody>
-                  <a:tcPr marL="91440" marR="91440" marT="45720" marB="45720">
+                  <a:tcPr>
                     <a:lnL w="6350" cap="flat" cmpd="sng" algn="ctr">
                       <a:solidFill>
                         <a:srgbClr val="475569"/>
@@ -5414,7 +5406,7 @@
                     <a:bodyPr/>
                     <a:lstStyle/>
                     <a:p>
-                      <a:pPr algn="ctr" indent="0" marL="0">
+                      <a:pPr marL="0" indent="0" algn="ctr">
                         <a:buNone/>
                       </a:pPr>
                       <a:r>
@@ -5435,7 +5427,7 @@
                       </a:endParaRPr>
                     </a:p>
                   </a:txBody>
-                  <a:tcPr marL="91440" marR="91440" marT="45720" marB="45720">
+                  <a:tcPr>
                     <a:lnL w="6350" cap="flat" cmpd="sng" algn="ctr">
                       <a:solidFill>
                         <a:srgbClr val="475569"/>
@@ -5482,7 +5474,7 @@
                     <a:bodyPr/>
                     <a:lstStyle/>
                     <a:p>
-                      <a:pPr algn="ctr" indent="0" marL="0">
+                      <a:pPr marL="0" indent="0" algn="ctr">
                         <a:buNone/>
                       </a:pPr>
                       <a:r>
@@ -5503,7 +5495,7 @@
                       </a:endParaRPr>
                     </a:p>
                   </a:txBody>
-                  <a:tcPr marL="91440" marR="91440" marT="45720" marB="45720">
+                  <a:tcPr>
                     <a:lnL w="6350" cap="flat" cmpd="sng" algn="ctr">
                       <a:solidFill>
                         <a:srgbClr val="475569"/>
@@ -5550,7 +5542,7 @@
                     <a:bodyPr/>
                     <a:lstStyle/>
                     <a:p>
-                      <a:pPr algn="ctr" indent="0" marL="0">
+                      <a:pPr marL="0" indent="0" algn="ctr">
                         <a:buNone/>
                       </a:pPr>
                       <a:r>
@@ -5571,7 +5563,7 @@
                       </a:endParaRPr>
                     </a:p>
                   </a:txBody>
-                  <a:tcPr marL="91440" marR="91440" marT="45720" marB="45720">
+                  <a:tcPr>
                     <a:lnL w="6350" cap="flat" cmpd="sng" algn="ctr">
                       <a:solidFill>
                         <a:srgbClr val="475569"/>
@@ -5613,6 +5605,11 @@
                     </a:solidFill>
                   </a:tcPr>
                 </a:tc>
+                <a:extLst>
+                  <a:ext uri="{0D108BD9-81ED-4DB2-BD59-A6C34878D82A}">
+                    <a16:rowId xmlns:a16="http://schemas.microsoft.com/office/drawing/2014/main" val="10004"/>
+                  </a:ext>
+                </a:extLst>
               </a:tr>
               <a:tr h="457200">
                 <a:tc>
@@ -5620,7 +5617,7 @@
                     <a:bodyPr/>
                     <a:lstStyle/>
                     <a:p>
-                      <a:pPr indent="0" marL="0">
+                      <a:pPr marL="0" indent="0">
                         <a:buNone/>
                       </a:pPr>
                       <a:r>
@@ -5641,7 +5638,7 @@
                       </a:endParaRPr>
                     </a:p>
                   </a:txBody>
-                  <a:tcPr marL="91440" marR="91440" marT="45720" marB="45720">
+                  <a:tcPr>
                     <a:lnL w="6350" cap="flat" cmpd="sng" algn="ctr">
                       <a:solidFill>
                         <a:srgbClr val="475569"/>
@@ -5688,7 +5685,7 @@
                     <a:bodyPr/>
                     <a:lstStyle/>
                     <a:p>
-                      <a:pPr algn="ctr" indent="0" marL="0">
+                      <a:pPr marL="0" indent="0" algn="ctr">
                         <a:buNone/>
                       </a:pPr>
                       <a:r>
@@ -5709,7 +5706,7 @@
                       </a:endParaRPr>
                     </a:p>
                   </a:txBody>
-                  <a:tcPr marL="91440" marR="91440" marT="45720" marB="45720">
+                  <a:tcPr>
                     <a:lnL w="6350" cap="flat" cmpd="sng" algn="ctr">
                       <a:solidFill>
                         <a:srgbClr val="475569"/>
@@ -5756,7 +5753,7 @@
                     <a:bodyPr/>
                     <a:lstStyle/>
                     <a:p>
-                      <a:pPr algn="ctr" indent="0" marL="0">
+                      <a:pPr marL="0" indent="0" algn="ctr">
                         <a:buNone/>
                       </a:pPr>
                       <a:r>
@@ -5777,7 +5774,7 @@
                       </a:endParaRPr>
                     </a:p>
                   </a:txBody>
-                  <a:tcPr marL="91440" marR="91440" marT="45720" marB="45720">
+                  <a:tcPr>
                     <a:lnL w="6350" cap="flat" cmpd="sng" algn="ctr">
                       <a:solidFill>
                         <a:srgbClr val="475569"/>
@@ -5824,7 +5821,7 @@
                     <a:bodyPr/>
                     <a:lstStyle/>
                     <a:p>
-                      <a:pPr algn="ctr" indent="0" marL="0">
+                      <a:pPr marL="0" indent="0" algn="ctr">
                         <a:buNone/>
                       </a:pPr>
                       <a:r>
@@ -5845,7 +5842,7 @@
                       </a:endParaRPr>
                     </a:p>
                   </a:txBody>
-                  <a:tcPr marL="91440" marR="91440" marT="45720" marB="45720">
+                  <a:tcPr>
                     <a:lnL w="6350" cap="flat" cmpd="sng" algn="ctr">
                       <a:solidFill>
                         <a:srgbClr val="475569"/>
@@ -5887,6 +5884,11 @@
                     </a:solidFill>
                   </a:tcPr>
                 </a:tc>
+                <a:extLst>
+                  <a:ext uri="{0D108BD9-81ED-4DB2-BD59-A6C34878D82A}">
+                    <a16:rowId xmlns:a16="http://schemas.microsoft.com/office/drawing/2014/main" val="10005"/>
+                  </a:ext>
+                </a:extLst>
               </a:tr>
             </a:tbl>
           </a:graphicData>
@@ -5894,14 +5896,14 @@
       </p:graphicFrame>
       <p:pic>
         <p:nvPicPr>
-          <p:cNvPr id="5" name="Image 0" descr="preencoded.png">    </p:cNvPr>
+          <p:cNvPr id="5" name="Image 0" descr="preencoded.png"/>
           <p:cNvPicPr>
             <a:picLocks noChangeAspect="1"/>
           </p:cNvPicPr>
           <p:nvPr/>
         </p:nvPicPr>
         <p:blipFill>
-          <a:blip r:embed="rId1"/>
+          <a:blip r:embed="rId3"/>
           <a:stretch>
             <a:fillRect/>
           </a:stretch>
@@ -5937,7 +5939,7 @@
           <a:bodyPr wrap="square" lIns="0" tIns="0" rIns="0" bIns="0" rtlCol="0" anchor="ctr"/>
           <a:lstStyle/>
           <a:p>
-            <a:pPr indent="0" marL="0">
+            <a:pPr marL="0" indent="0">
               <a:buNone/>
             </a:pPr>
             <a:r>
@@ -5971,6 +5973,7 @@
         <a:solidFill>
           <a:srgbClr val="0F1729"/>
         </a:solidFill>
+        <a:effectLst/>
       </p:bgPr>
     </p:bg>
     <p:spTree>
@@ -6008,6 +6011,13 @@
           </a:solidFill>
           <a:ln/>
         </p:spPr>
+        <p:txBody>
+          <a:bodyPr/>
+          <a:lstStyle/>
+          <a:p>
+            <a:endParaRPr lang="en-US"/>
+          </a:p>
+        </p:txBody>
       </p:sp>
       <p:sp>
         <p:nvSpPr>
@@ -6030,7 +6040,7 @@
           <a:bodyPr wrap="square" lIns="0" tIns="0" rIns="0" bIns="0" rtlCol="0" anchor="ctr"/>
           <a:lstStyle/>
           <a:p>
-            <a:pPr indent="0" marL="0">
+            <a:pPr marL="0" indent="0">
               <a:buNone/>
             </a:pPr>
             <a:r>
@@ -6067,136 +6077,17 @@
           </a:solidFill>
           <a:ln/>
         </p:spPr>
+        <p:txBody>
+          <a:bodyPr/>
+          <a:lstStyle/>
+          <a:p>
+            <a:endParaRPr lang="en-US"/>
+          </a:p>
+        </p:txBody>
       </p:sp>
       <p:pic>
         <p:nvPicPr>
-          <p:cNvPr id="5" name="Image 0" descr="preencoded.png">    </p:cNvPr>
-          <p:cNvPicPr>
-            <a:picLocks noChangeAspect="1"/>
-          </p:cNvPicPr>
-          <p:nvPr/>
-        </p:nvPicPr>
-        <p:blipFill>
-          <a:blip r:embed="rId1"/>
-          <a:stretch>
-            <a:fillRect/>
-          </a:stretch>
-        </p:blipFill>
-        <p:spPr>
-          <a:xfrm>
-            <a:off x="914400" y="1417320"/>
-            <a:ext cx="320040" cy="320040"/>
-          </a:xfrm>
-          <a:prstGeom prst="rect">
-            <a:avLst/>
-          </a:prstGeom>
-        </p:spPr>
-      </p:pic>
-      <p:sp>
-        <p:nvSpPr>
-          <p:cNvPr id="6" name="Text 3"/>
-          <p:cNvSpPr/>
-          <p:nvPr/>
-        </p:nvSpPr>
-        <p:spPr>
-          <a:xfrm>
-            <a:off x="1463040" y="1371600"/>
-            <a:ext cx="6858000" cy="457200"/>
-          </a:xfrm>
-          <a:prstGeom prst="rect">
-            <a:avLst/>
-          </a:prstGeom>
-          <a:noFill/>
-          <a:ln/>
-        </p:spPr>
-        <p:txBody>
-          <a:bodyPr wrap="square" lIns="0" tIns="0" rIns="0" bIns="0" rtlCol="0" anchor="ctr"/>
-          <a:lstStyle/>
-          <a:p>
-            <a:pPr indent="0" marL="0">
-              <a:buNone/>
-            </a:pPr>
-            <a:r>
-              <a:rPr lang="en-US" sz="1600" dirty="0">
-                <a:solidFill>
-                  <a:srgbClr val="F8FAFC"/>
-                </a:solidFill>
-                <a:latin typeface="Calibri" pitchFamily="34" charset="0"/>
-                <a:ea typeface="Calibri" pitchFamily="34" charset="-122"/>
-                <a:cs typeface="Calibri" pitchFamily="34" charset="-120"/>
-              </a:rPr>
-              <a:t>State Management = Daten zur Laufzeit verwalten</a:t>
-            </a:r>
-            <a:endParaRPr lang="en-US" sz="1600" dirty="0"/>
-          </a:p>
-        </p:txBody>
-      </p:sp>
-      <p:pic>
-        <p:nvPicPr>
-          <p:cNvPr id="7" name="Image 1" descr="preencoded.png">    </p:cNvPr>
-          <p:cNvPicPr>
-            <a:picLocks noChangeAspect="1"/>
-          </p:cNvPicPr>
-          <p:nvPr/>
-        </p:nvPicPr>
-        <p:blipFill>
-          <a:blip r:embed="rId2"/>
-          <a:stretch>
-            <a:fillRect/>
-          </a:stretch>
-        </p:blipFill>
-        <p:spPr>
-          <a:xfrm>
-            <a:off x="914400" y="1965960"/>
-            <a:ext cx="320040" cy="320040"/>
-          </a:xfrm>
-          <a:prstGeom prst="rect">
-            <a:avLst/>
-          </a:prstGeom>
-        </p:spPr>
-      </p:pic>
-      <p:sp>
-        <p:nvSpPr>
-          <p:cNvPr id="8" name="Text 4"/>
-          <p:cNvSpPr/>
-          <p:nvPr/>
-        </p:nvSpPr>
-        <p:spPr>
-          <a:xfrm>
-            <a:off x="1463040" y="1920240"/>
-            <a:ext cx="6858000" cy="457200"/>
-          </a:xfrm>
-          <a:prstGeom prst="rect">
-            <a:avLst/>
-          </a:prstGeom>
-          <a:noFill/>
-          <a:ln/>
-        </p:spPr>
-        <p:txBody>
-          <a:bodyPr wrap="square" lIns="0" tIns="0" rIns="0" bIns="0" rtlCol="0" anchor="ctr"/>
-          <a:lstStyle/>
-          <a:p>
-            <a:pPr indent="0" marL="0">
-              <a:buNone/>
-            </a:pPr>
-            <a:r>
-              <a:rPr lang="en-US" sz="1600" dirty="0">
-                <a:solidFill>
-                  <a:srgbClr val="F8FAFC"/>
-                </a:solidFill>
-                <a:latin typeface="Calibri" pitchFamily="34" charset="0"/>
-                <a:ea typeface="Calibri" pitchFamily="34" charset="-122"/>
-                <a:cs typeface="Calibri" pitchFamily="34" charset="-120"/>
-              </a:rPr>
-              <a:t>useState für einfache, lokale Werte</a:t>
-            </a:r>
-            <a:endParaRPr lang="en-US" sz="1600" dirty="0"/>
-          </a:p>
-        </p:txBody>
-      </p:sp>
-      <p:pic>
-        <p:nvPicPr>
-          <p:cNvPr id="9" name="Image 2" descr="preencoded.png">    </p:cNvPr>
+          <p:cNvPr id="5" name="Image 0" descr="preencoded.png"/>
           <p:cNvPicPr>
             <a:picLocks noChangeAspect="1"/>
           </p:cNvPicPr>
@@ -6210,7 +6101,7 @@
         </p:blipFill>
         <p:spPr>
           <a:xfrm>
-            <a:off x="914400" y="2514600"/>
+            <a:off x="914400" y="1417320"/>
             <a:ext cx="320040" cy="320040"/>
           </a:xfrm>
           <a:prstGeom prst="rect">
@@ -6220,13 +6111,13 @@
       </p:pic>
       <p:sp>
         <p:nvSpPr>
-          <p:cNvPr id="10" name="Text 5"/>
-          <p:cNvSpPr/>
-          <p:nvPr/>
-        </p:nvSpPr>
-        <p:spPr>
-          <a:xfrm>
-            <a:off x="1463040" y="2468880"/>
+          <p:cNvPr id="6" name="Text 3"/>
+          <p:cNvSpPr/>
+          <p:nvPr/>
+        </p:nvSpPr>
+        <p:spPr>
+          <a:xfrm>
+            <a:off x="1463040" y="1371600"/>
             <a:ext cx="6858000" cy="457200"/>
           </a:xfrm>
           <a:prstGeom prst="rect">
@@ -6239,7 +6130,7 @@
           <a:bodyPr wrap="square" lIns="0" tIns="0" rIns="0" bIns="0" rtlCol="0" anchor="ctr"/>
           <a:lstStyle/>
           <a:p>
-            <a:pPr indent="0" marL="0">
+            <a:pPr marL="0" indent="0">
               <a:buNone/>
             </a:pPr>
             <a:r>
@@ -6251,7 +6142,7 @@
                 <a:ea typeface="Calibri" pitchFamily="34" charset="-122"/>
                 <a:cs typeface="Calibri" pitchFamily="34" charset="-120"/>
               </a:rPr>
-              <a:t>useReducer für komplexe, zusammenhängende Logik</a:t>
+              <a:t>State Management = Daten zur Laufzeit verwalten</a:t>
             </a:r>
             <a:endParaRPr lang="en-US" sz="1600" dirty="0"/>
           </a:p>
@@ -6259,21 +6150,21 @@
       </p:sp>
       <p:pic>
         <p:nvPicPr>
-          <p:cNvPr id="11" name="Image 3" descr="preencoded.png">    </p:cNvPr>
+          <p:cNvPr id="7" name="Image 1" descr="preencoded.png"/>
           <p:cNvPicPr>
             <a:picLocks noChangeAspect="1"/>
           </p:cNvPicPr>
           <p:nvPr/>
         </p:nvPicPr>
         <p:blipFill>
-          <a:blip r:embed="rId4"/>
+          <a:blip r:embed="rId3"/>
           <a:stretch>
             <a:fillRect/>
           </a:stretch>
         </p:blipFill>
         <p:spPr>
           <a:xfrm>
-            <a:off x="914400" y="3063240"/>
+            <a:off x="914400" y="1965960"/>
             <a:ext cx="320040" cy="320040"/>
           </a:xfrm>
           <a:prstGeom prst="rect">
@@ -6283,13 +6174,13 @@
       </p:pic>
       <p:sp>
         <p:nvSpPr>
-          <p:cNvPr id="12" name="Text 6"/>
-          <p:cNvSpPr/>
-          <p:nvPr/>
-        </p:nvSpPr>
-        <p:spPr>
-          <a:xfrm>
-            <a:off x="1463040" y="3017520"/>
+          <p:cNvPr id="8" name="Text 4"/>
+          <p:cNvSpPr/>
+          <p:nvPr/>
+        </p:nvSpPr>
+        <p:spPr>
+          <a:xfrm>
+            <a:off x="1463040" y="1920240"/>
             <a:ext cx="6858000" cy="457200"/>
           </a:xfrm>
           <a:prstGeom prst="rect">
@@ -6302,7 +6193,7 @@
           <a:bodyPr wrap="square" lIns="0" tIns="0" rIns="0" bIns="0" rtlCol="0" anchor="ctr"/>
           <a:lstStyle/>
           <a:p>
-            <a:pPr indent="0" marL="0">
+            <a:pPr marL="0" indent="0">
               <a:buNone/>
             </a:pPr>
             <a:r>
@@ -6314,7 +6205,7 @@
                 <a:ea typeface="Calibri" pitchFamily="34" charset="-122"/>
                 <a:cs typeface="Calibri" pitchFamily="34" charset="-120"/>
               </a:rPr>
-              <a:t>Context API löst Prop Drilling</a:t>
+              <a:t>useState für einfache, lokale Werte</a:t>
             </a:r>
             <a:endParaRPr lang="en-US" sz="1600" dirty="0"/>
           </a:p>
@@ -6322,21 +6213,21 @@
       </p:sp>
       <p:pic>
         <p:nvPicPr>
-          <p:cNvPr id="13" name="Image 4" descr="preencoded.png">    </p:cNvPr>
+          <p:cNvPr id="9" name="Image 2" descr="preencoded.png"/>
           <p:cNvPicPr>
             <a:picLocks noChangeAspect="1"/>
           </p:cNvPicPr>
           <p:nvPr/>
         </p:nvPicPr>
         <p:blipFill>
-          <a:blip r:embed="rId5"/>
+          <a:blip r:embed="rId3"/>
           <a:stretch>
             <a:fillRect/>
           </a:stretch>
         </p:blipFill>
         <p:spPr>
           <a:xfrm>
-            <a:off x="914400" y="3611880"/>
+            <a:off x="914400" y="2514600"/>
             <a:ext cx="320040" cy="320040"/>
           </a:xfrm>
           <a:prstGeom prst="rect">
@@ -6346,13 +6237,13 @@
       </p:pic>
       <p:sp>
         <p:nvSpPr>
-          <p:cNvPr id="14" name="Text 7"/>
-          <p:cNvSpPr/>
-          <p:nvPr/>
-        </p:nvSpPr>
-        <p:spPr>
-          <a:xfrm>
-            <a:off x="1463040" y="3566160"/>
+          <p:cNvPr id="10" name="Text 5"/>
+          <p:cNvSpPr/>
+          <p:nvPr/>
+        </p:nvSpPr>
+        <p:spPr>
+          <a:xfrm>
+            <a:off x="1463040" y="2468880"/>
             <a:ext cx="6858000" cy="457200"/>
           </a:xfrm>
           <a:prstGeom prst="rect">
@@ -6365,7 +6256,7 @@
           <a:bodyPr wrap="square" lIns="0" tIns="0" rIns="0" bIns="0" rtlCol="0" anchor="ctr"/>
           <a:lstStyle/>
           <a:p>
-            <a:pPr indent="0" marL="0">
+            <a:pPr marL="0" indent="0">
               <a:buNone/>
             </a:pPr>
             <a:r>
@@ -6377,7 +6268,7 @@
                 <a:ea typeface="Calibri" pitchFamily="34" charset="-122"/>
                 <a:cs typeface="Calibri" pitchFamily="34" charset="-120"/>
               </a:rPr>
-              <a:t>Externe Libs (Zustand, Redux) für große Projekte</a:t>
+              <a:t>useReducer für komplexe, zusammenhängende Logik</a:t>
             </a:r>
             <a:endParaRPr lang="en-US" sz="1600" dirty="0"/>
           </a:p>
@@ -6385,20 +6276,146 @@
       </p:sp>
       <p:pic>
         <p:nvPicPr>
-          <p:cNvPr id="15" name="Image 5" descr="preencoded.png">    </p:cNvPr>
+          <p:cNvPr id="11" name="Image 3" descr="preencoded.png"/>
           <p:cNvPicPr>
             <a:picLocks noChangeAspect="1"/>
           </p:cNvPicPr>
           <p:nvPr/>
         </p:nvPicPr>
         <p:blipFill>
-          <a:blip r:embed="rId6"/>
+          <a:blip r:embed="rId3"/>
           <a:stretch>
             <a:fillRect/>
           </a:stretch>
         </p:blipFill>
         <p:spPr>
           <a:xfrm>
+            <a:off x="914400" y="3063240"/>
+            <a:ext cx="320040" cy="320040"/>
+          </a:xfrm>
+          <a:prstGeom prst="rect">
+            <a:avLst/>
+          </a:prstGeom>
+        </p:spPr>
+      </p:pic>
+      <p:sp>
+        <p:nvSpPr>
+          <p:cNvPr id="12" name="Text 6"/>
+          <p:cNvSpPr/>
+          <p:nvPr/>
+        </p:nvSpPr>
+        <p:spPr>
+          <a:xfrm>
+            <a:off x="1463040" y="3017520"/>
+            <a:ext cx="6858000" cy="457200"/>
+          </a:xfrm>
+          <a:prstGeom prst="rect">
+            <a:avLst/>
+          </a:prstGeom>
+          <a:noFill/>
+          <a:ln/>
+        </p:spPr>
+        <p:txBody>
+          <a:bodyPr wrap="square" lIns="0" tIns="0" rIns="0" bIns="0" rtlCol="0" anchor="ctr"/>
+          <a:lstStyle/>
+          <a:p>
+            <a:pPr marL="0" indent="0">
+              <a:buNone/>
+            </a:pPr>
+            <a:r>
+              <a:rPr lang="en-US" sz="1600" dirty="0">
+                <a:solidFill>
+                  <a:srgbClr val="F8FAFC"/>
+                </a:solidFill>
+                <a:latin typeface="Calibri" pitchFamily="34" charset="0"/>
+                <a:ea typeface="Calibri" pitchFamily="34" charset="-122"/>
+                <a:cs typeface="Calibri" pitchFamily="34" charset="-120"/>
+              </a:rPr>
+              <a:t>Context API löst Prop Drilling</a:t>
+            </a:r>
+            <a:endParaRPr lang="en-US" sz="1600" dirty="0"/>
+          </a:p>
+        </p:txBody>
+      </p:sp>
+      <p:pic>
+        <p:nvPicPr>
+          <p:cNvPr id="13" name="Image 4" descr="preencoded.png"/>
+          <p:cNvPicPr>
+            <a:picLocks noChangeAspect="1"/>
+          </p:cNvPicPr>
+          <p:nvPr/>
+        </p:nvPicPr>
+        <p:blipFill>
+          <a:blip r:embed="rId3"/>
+          <a:stretch>
+            <a:fillRect/>
+          </a:stretch>
+        </p:blipFill>
+        <p:spPr>
+          <a:xfrm>
+            <a:off x="914400" y="3611880"/>
+            <a:ext cx="320040" cy="320040"/>
+          </a:xfrm>
+          <a:prstGeom prst="rect">
+            <a:avLst/>
+          </a:prstGeom>
+        </p:spPr>
+      </p:pic>
+      <p:sp>
+        <p:nvSpPr>
+          <p:cNvPr id="14" name="Text 7"/>
+          <p:cNvSpPr/>
+          <p:nvPr/>
+        </p:nvSpPr>
+        <p:spPr>
+          <a:xfrm>
+            <a:off x="1463040" y="3566160"/>
+            <a:ext cx="6858000" cy="457200"/>
+          </a:xfrm>
+          <a:prstGeom prst="rect">
+            <a:avLst/>
+          </a:prstGeom>
+          <a:noFill/>
+          <a:ln/>
+        </p:spPr>
+        <p:txBody>
+          <a:bodyPr wrap="square" lIns="0" tIns="0" rIns="0" bIns="0" rtlCol="0" anchor="ctr"/>
+          <a:lstStyle/>
+          <a:p>
+            <a:pPr marL="0" indent="0">
+              <a:buNone/>
+            </a:pPr>
+            <a:r>
+              <a:rPr lang="en-US" sz="1600" dirty="0">
+                <a:solidFill>
+                  <a:srgbClr val="F8FAFC"/>
+                </a:solidFill>
+                <a:latin typeface="Calibri" pitchFamily="34" charset="0"/>
+                <a:ea typeface="Calibri" pitchFamily="34" charset="-122"/>
+                <a:cs typeface="Calibri" pitchFamily="34" charset="-120"/>
+              </a:rPr>
+              <a:t>Externe Libs (Zustand, Redux) für große Projekte</a:t>
+            </a:r>
+            <a:endParaRPr lang="en-US" sz="1600" dirty="0"/>
+          </a:p>
+        </p:txBody>
+      </p:sp>
+      <p:pic>
+        <p:nvPicPr>
+          <p:cNvPr id="15" name="Image 5" descr="preencoded.png"/>
+          <p:cNvPicPr>
+            <a:picLocks noChangeAspect="1"/>
+          </p:cNvPicPr>
+          <p:nvPr/>
+        </p:nvPicPr>
+        <p:blipFill>
+          <a:blip r:embed="rId3"/>
+          <a:stretch>
+            <a:fillRect/>
+          </a:stretch>
+        </p:blipFill>
+        <p:spPr>
+          <a:xfrm>
             <a:off x="914400" y="4160520"/>
             <a:ext cx="320040" cy="320040"/>
           </a:xfrm>
@@ -6428,7 +6445,7 @@
           <a:bodyPr wrap="square" lIns="0" tIns="0" rIns="0" bIns="0" rtlCol="0" anchor="ctr"/>
           <a:lstStyle/>
           <a:p>
-            <a:pPr indent="0" marL="0">
+            <a:pPr marL="0" indent="0">
               <a:buNone/>
             </a:pPr>
             <a:r>
@@ -6462,6 +6479,7 @@
         <a:solidFill>
           <a:srgbClr val="0F1729"/>
         </a:solidFill>
+        <a:effectLst/>
       </p:bgPr>
     </p:bg>
     <p:spTree>
@@ -6499,6 +6517,13 @@
           </a:solidFill>
           <a:ln/>
         </p:spPr>
+        <p:txBody>
+          <a:bodyPr/>
+          <a:lstStyle/>
+          <a:p>
+            <a:endParaRPr lang="en-US"/>
+          </a:p>
+        </p:txBody>
       </p:sp>
       <p:sp>
         <p:nvSpPr>
@@ -6521,6 +6546,13 @@
           </a:solidFill>
           <a:ln/>
         </p:spPr>
+        <p:txBody>
+          <a:bodyPr/>
+          <a:lstStyle/>
+          <a:p>
+            <a:endParaRPr lang="en-US"/>
+          </a:p>
+        </p:txBody>
       </p:sp>
       <p:sp>
         <p:nvSpPr>
@@ -6543,7 +6575,7 @@
           <a:bodyPr wrap="square" lIns="0" tIns="0" rIns="0" bIns="0" rtlCol="0" anchor="ctr"/>
           <a:lstStyle/>
           <a:p>
-            <a:pPr algn="ctr" indent="0" marL="0">
+            <a:pPr marL="0" indent="0" algn="ctr">
               <a:buNone/>
             </a:pPr>
             <a:r>
@@ -6582,7 +6614,7 @@
           <a:bodyPr wrap="square" lIns="0" tIns="0" rIns="0" bIns="0" rtlCol="0" anchor="ctr"/>
           <a:lstStyle/>
           <a:p>
-            <a:pPr algn="ctr" indent="0" marL="0">
+            <a:pPr marL="0" indent="0" algn="ctr">
               <a:buNone/>
             </a:pPr>
             <a:r>
@@ -6616,6 +6648,7 @@
         <a:solidFill>
           <a:srgbClr val="0F1729"/>
         </a:solidFill>
+        <a:effectLst/>
       </p:bgPr>
     </p:bg>
     <p:spTree>
@@ -6653,7 +6686,7 @@
           <a:bodyPr wrap="square" lIns="0" tIns="0" rIns="0" bIns="0" rtlCol="0" anchor="ctr"/>
           <a:lstStyle/>
           <a:p>
-            <a:pPr indent="0" marL="0">
+            <a:pPr marL="0" indent="0">
               <a:buNone/>
             </a:pPr>
             <a:r>
@@ -6690,6 +6723,13 @@
           </a:solidFill>
           <a:ln/>
         </p:spPr>
+        <p:txBody>
+          <a:bodyPr/>
+          <a:lstStyle/>
+          <a:p>
+            <a:endParaRPr lang="en-US"/>
+          </a:p>
+        </p:txBody>
       </p:sp>
       <p:sp>
         <p:nvSpPr>
@@ -6712,258 +6752,17 @@
           </a:solidFill>
           <a:ln/>
         </p:spPr>
+        <p:txBody>
+          <a:bodyPr/>
+          <a:lstStyle/>
+          <a:p>
+            <a:endParaRPr lang="en-US"/>
+          </a:p>
+        </p:txBody>
       </p:sp>
       <p:pic>
         <p:nvPicPr>
-          <p:cNvPr id="5" name="Image 0" descr="preencoded.png">    </p:cNvPr>
-          <p:cNvPicPr>
-            <a:picLocks noChangeAspect="1"/>
-          </p:cNvPicPr>
-          <p:nvPr/>
-        </p:nvPicPr>
-        <p:blipFill>
-          <a:blip r:embed="rId1"/>
-          <a:stretch>
-            <a:fillRect/>
-          </a:stretch>
-        </p:blipFill>
-        <p:spPr>
-          <a:xfrm>
-            <a:off x="914400" y="1463040"/>
-            <a:ext cx="320040" cy="320040"/>
-          </a:xfrm>
-          <a:prstGeom prst="rect">
-            <a:avLst/>
-          </a:prstGeom>
-        </p:spPr>
-      </p:pic>
-      <p:sp>
-        <p:nvSpPr>
-          <p:cNvPr id="6" name="Text 3"/>
-          <p:cNvSpPr/>
-          <p:nvPr/>
-        </p:nvSpPr>
-        <p:spPr>
-          <a:xfrm>
-            <a:off x="1417320" y="1371600"/>
-            <a:ext cx="3200400" cy="502920"/>
-          </a:xfrm>
-          <a:prstGeom prst="rect">
-            <a:avLst/>
-          </a:prstGeom>
-          <a:noFill/>
-          <a:ln/>
-        </p:spPr>
-        <p:txBody>
-          <a:bodyPr wrap="square" lIns="0" tIns="0" rIns="0" bIns="0" rtlCol="0" anchor="ctr"/>
-          <a:lstStyle/>
-          <a:p>
-            <a:pPr indent="0" marL="0">
-              <a:buNone/>
-            </a:pPr>
-            <a:r>
-              <a:rPr lang="en-US" sz="1500" b="1" dirty="0">
-                <a:solidFill>
-                  <a:srgbClr val="F8FAFC"/>
-                </a:solidFill>
-                <a:latin typeface="Trebuchet MS" pitchFamily="34" charset="0"/>
-                <a:ea typeface="Trebuchet MS" pitchFamily="34" charset="-122"/>
-                <a:cs typeface="Trebuchet MS" pitchFamily="34" charset="-120"/>
-              </a:rPr>
-              <a:t>Warum State Management?</a:t>
-            </a:r>
-            <a:endParaRPr lang="en-US" sz="1500" dirty="0"/>
-          </a:p>
-        </p:txBody>
-      </p:sp>
-      <p:sp>
-        <p:nvSpPr>
-          <p:cNvPr id="7" name="Text 4"/>
-          <p:cNvSpPr/>
-          <p:nvPr/>
-        </p:nvSpPr>
-        <p:spPr>
-          <a:xfrm>
-            <a:off x="4754880" y="1371600"/>
-            <a:ext cx="3474720" cy="502920"/>
-          </a:xfrm>
-          <a:prstGeom prst="rect">
-            <a:avLst/>
-          </a:prstGeom>
-          <a:noFill/>
-          <a:ln/>
-        </p:spPr>
-        <p:txBody>
-          <a:bodyPr wrap="square" lIns="0" tIns="0" rIns="0" bIns="0" rtlCol="0" anchor="ctr"/>
-          <a:lstStyle/>
-          <a:p>
-            <a:pPr indent="0" marL="0">
-              <a:buNone/>
-            </a:pPr>
-            <a:r>
-              <a:rPr lang="en-US" sz="1300" dirty="0">
-                <a:solidFill>
-                  <a:srgbClr val="94A3B8"/>
-                </a:solidFill>
-                <a:latin typeface="Calibri" pitchFamily="34" charset="0"/>
-                <a:ea typeface="Calibri" pitchFamily="34" charset="-122"/>
-                <a:cs typeface="Calibri" pitchFamily="34" charset="-120"/>
-              </a:rPr>
-              <a:t>Das Problem mit Prop Drilling</a:t>
-            </a:r>
-            <a:endParaRPr lang="en-US" sz="1300" dirty="0"/>
-          </a:p>
-        </p:txBody>
-      </p:sp>
-      <p:sp>
-        <p:nvSpPr>
-          <p:cNvPr id="8" name="Shape 5"/>
-          <p:cNvSpPr/>
-          <p:nvPr/>
-        </p:nvSpPr>
-        <p:spPr>
-          <a:xfrm>
-            <a:off x="731520" y="1965960"/>
-            <a:ext cx="7680960" cy="502920"/>
-          </a:xfrm>
-          <a:prstGeom prst="roundRect">
-            <a:avLst>
-              <a:gd name="adj" fmla="val 9091"/>
-            </a:avLst>
-          </a:prstGeom>
-          <a:solidFill>
-            <a:srgbClr val="1A2744"/>
-          </a:solidFill>
-          <a:ln/>
-        </p:spPr>
-      </p:sp>
-      <p:pic>
-        <p:nvPicPr>
-          <p:cNvPr id="9" name="Image 1" descr="preencoded.png">    </p:cNvPr>
-          <p:cNvPicPr>
-            <a:picLocks noChangeAspect="1"/>
-          </p:cNvPicPr>
-          <p:nvPr/>
-        </p:nvPicPr>
-        <p:blipFill>
-          <a:blip r:embed="rId2"/>
-          <a:stretch>
-            <a:fillRect/>
-          </a:stretch>
-        </p:blipFill>
-        <p:spPr>
-          <a:xfrm>
-            <a:off x="914400" y="2057400"/>
-            <a:ext cx="320040" cy="320040"/>
-          </a:xfrm>
-          <a:prstGeom prst="rect">
-            <a:avLst/>
-          </a:prstGeom>
-        </p:spPr>
-      </p:pic>
-      <p:sp>
-        <p:nvSpPr>
-          <p:cNvPr id="10" name="Text 6"/>
-          <p:cNvSpPr/>
-          <p:nvPr/>
-        </p:nvSpPr>
-        <p:spPr>
-          <a:xfrm>
-            <a:off x="1417320" y="1965960"/>
-            <a:ext cx="3200400" cy="502920"/>
-          </a:xfrm>
-          <a:prstGeom prst="rect">
-            <a:avLst/>
-          </a:prstGeom>
-          <a:noFill/>
-          <a:ln/>
-        </p:spPr>
-        <p:txBody>
-          <a:bodyPr wrap="square" lIns="0" tIns="0" rIns="0" bIns="0" rtlCol="0" anchor="ctr"/>
-          <a:lstStyle/>
-          <a:p>
-            <a:pPr indent="0" marL="0">
-              <a:buNone/>
-            </a:pPr>
-            <a:r>
-              <a:rPr lang="en-US" sz="1500" b="1" dirty="0">
-                <a:solidFill>
-                  <a:srgbClr val="F8FAFC"/>
-                </a:solidFill>
-                <a:latin typeface="Trebuchet MS" pitchFamily="34" charset="0"/>
-                <a:ea typeface="Trebuchet MS" pitchFamily="34" charset="-122"/>
-                <a:cs typeface="Trebuchet MS" pitchFamily="34" charset="-120"/>
-              </a:rPr>
-              <a:t>useState – Recap &amp; Grenzen</a:t>
-            </a:r>
-            <a:endParaRPr lang="en-US" sz="1500" dirty="0"/>
-          </a:p>
-        </p:txBody>
-      </p:sp>
-      <p:sp>
-        <p:nvSpPr>
-          <p:cNvPr id="11" name="Text 7"/>
-          <p:cNvSpPr/>
-          <p:nvPr/>
-        </p:nvSpPr>
-        <p:spPr>
-          <a:xfrm>
-            <a:off x="4754880" y="1965960"/>
-            <a:ext cx="3474720" cy="502920"/>
-          </a:xfrm>
-          <a:prstGeom prst="rect">
-            <a:avLst/>
-          </a:prstGeom>
-          <a:noFill/>
-          <a:ln/>
-        </p:spPr>
-        <p:txBody>
-          <a:bodyPr wrap="square" lIns="0" tIns="0" rIns="0" bIns="0" rtlCol="0" anchor="ctr"/>
-          <a:lstStyle/>
-          <a:p>
-            <a:pPr indent="0" marL="0">
-              <a:buNone/>
-            </a:pPr>
-            <a:r>
-              <a:rPr lang="en-US" sz="1300" dirty="0">
-                <a:solidFill>
-                  <a:srgbClr val="94A3B8"/>
-                </a:solidFill>
-                <a:latin typeface="Calibri" pitchFamily="34" charset="0"/>
-                <a:ea typeface="Calibri" pitchFamily="34" charset="-122"/>
-                <a:cs typeface="Calibri" pitchFamily="34" charset="-120"/>
-              </a:rPr>
-              <a:t>Wann reicht useState nicht mehr?</a:t>
-            </a:r>
-            <a:endParaRPr lang="en-US" sz="1300" dirty="0"/>
-          </a:p>
-        </p:txBody>
-      </p:sp>
-      <p:sp>
-        <p:nvSpPr>
-          <p:cNvPr id="12" name="Shape 8"/>
-          <p:cNvSpPr/>
-          <p:nvPr/>
-        </p:nvSpPr>
-        <p:spPr>
-          <a:xfrm>
-            <a:off x="731520" y="2560320"/>
-            <a:ext cx="7680960" cy="502920"/>
-          </a:xfrm>
-          <a:prstGeom prst="roundRect">
-            <a:avLst>
-              <a:gd name="adj" fmla="val 9091"/>
-            </a:avLst>
-          </a:prstGeom>
-          <a:solidFill>
-            <a:srgbClr val="1A2744"/>
-          </a:solidFill>
-          <a:ln/>
-        </p:spPr>
-      </p:sp>
-      <p:pic>
-        <p:nvPicPr>
-          <p:cNvPr id="13" name="Image 2" descr="preencoded.png">    </p:cNvPr>
+          <p:cNvPr id="5" name="Image 0" descr="preencoded.png"/>
           <p:cNvPicPr>
             <a:picLocks noChangeAspect="1"/>
           </p:cNvPicPr>
@@ -6977,7 +6776,7 @@
         </p:blipFill>
         <p:spPr>
           <a:xfrm>
-            <a:off x="914400" y="2651760"/>
+            <a:off x="914400" y="1463040"/>
             <a:ext cx="320040" cy="320040"/>
           </a:xfrm>
           <a:prstGeom prst="rect">
@@ -6987,13 +6786,13 @@
       </p:pic>
       <p:sp>
         <p:nvSpPr>
-          <p:cNvPr id="14" name="Text 9"/>
-          <p:cNvSpPr/>
-          <p:nvPr/>
-        </p:nvSpPr>
-        <p:spPr>
-          <a:xfrm>
-            <a:off x="1417320" y="2560320"/>
+          <p:cNvPr id="6" name="Text 3"/>
+          <p:cNvSpPr/>
+          <p:nvPr/>
+        </p:nvSpPr>
+        <p:spPr>
+          <a:xfrm>
+            <a:off x="1417320" y="1371600"/>
             <a:ext cx="3200400" cy="502920"/>
           </a:xfrm>
           <a:prstGeom prst="rect">
@@ -7006,7 +6805,7 @@
           <a:bodyPr wrap="square" lIns="0" tIns="0" rIns="0" bIns="0" rtlCol="0" anchor="ctr"/>
           <a:lstStyle/>
           <a:p>
-            <a:pPr indent="0" marL="0">
+            <a:pPr marL="0" indent="0">
               <a:buNone/>
             </a:pPr>
             <a:r>
@@ -7018,7 +6817,7 @@
                 <a:ea typeface="Trebuchet MS" pitchFamily="34" charset="-122"/>
                 <a:cs typeface="Trebuchet MS" pitchFamily="34" charset="-120"/>
               </a:rPr>
-              <a:t>useReducer</a:t>
+              <a:t>Warum State Management?</a:t>
             </a:r>
             <a:endParaRPr lang="en-US" sz="1500" dirty="0"/>
           </a:p>
@@ -7026,13 +6825,13 @@
       </p:sp>
       <p:sp>
         <p:nvSpPr>
-          <p:cNvPr id="15" name="Text 10"/>
-          <p:cNvSpPr/>
-          <p:nvPr/>
-        </p:nvSpPr>
-        <p:spPr>
-          <a:xfrm>
-            <a:off x="4754880" y="2560320"/>
+          <p:cNvPr id="7" name="Text 4"/>
+          <p:cNvSpPr/>
+          <p:nvPr/>
+        </p:nvSpPr>
+        <p:spPr>
+          <a:xfrm>
+            <a:off x="4754880" y="1371600"/>
             <a:ext cx="3474720" cy="502920"/>
           </a:xfrm>
           <a:prstGeom prst="rect">
@@ -7045,7 +6844,7 @@
           <a:bodyPr wrap="square" lIns="0" tIns="0" rIns="0" bIns="0" rtlCol="0" anchor="ctr"/>
           <a:lstStyle/>
           <a:p>
-            <a:pPr indent="0" marL="0">
+            <a:pPr marL="0" indent="0">
               <a:buNone/>
             </a:pPr>
             <a:r>
@@ -7057,7 +6856,7 @@
                 <a:ea typeface="Calibri" pitchFamily="34" charset="-122"/>
                 <a:cs typeface="Calibri" pitchFamily="34" charset="-120"/>
               </a:rPr>
-              <a:t>Komplexen State strukturieren</a:t>
+              <a:t>Das Problem mit Prop Drilling</a:t>
             </a:r>
             <a:endParaRPr lang="en-US" sz="1300" dirty="0"/>
           </a:p>
@@ -7065,13 +6864,13 @@
       </p:sp>
       <p:sp>
         <p:nvSpPr>
-          <p:cNvPr id="16" name="Shape 11"/>
-          <p:cNvSpPr/>
-          <p:nvPr/>
-        </p:nvSpPr>
-        <p:spPr>
-          <a:xfrm>
-            <a:off x="731520" y="3154680"/>
+          <p:cNvPr id="8" name="Shape 5"/>
+          <p:cNvSpPr/>
+          <p:nvPr/>
+        </p:nvSpPr>
+        <p:spPr>
+          <a:xfrm>
+            <a:off x="731520" y="1965960"/>
             <a:ext cx="7680960" cy="502920"/>
           </a:xfrm>
           <a:prstGeom prst="roundRect">
@@ -7084,10 +6883,17 @@
           </a:solidFill>
           <a:ln/>
         </p:spPr>
+        <p:txBody>
+          <a:bodyPr/>
+          <a:lstStyle/>
+          <a:p>
+            <a:endParaRPr lang="en-US"/>
+          </a:p>
+        </p:txBody>
       </p:sp>
       <p:pic>
         <p:nvPicPr>
-          <p:cNvPr id="17" name="Image 3" descr="preencoded.png">    </p:cNvPr>
+          <p:cNvPr id="9" name="Image 1" descr="preencoded.png"/>
           <p:cNvPicPr>
             <a:picLocks noChangeAspect="1"/>
           </p:cNvPicPr>
@@ -7101,7 +6907,7 @@
         </p:blipFill>
         <p:spPr>
           <a:xfrm>
-            <a:off x="914400" y="3246120"/>
+            <a:off x="914400" y="2057400"/>
             <a:ext cx="320040" cy="320040"/>
           </a:xfrm>
           <a:prstGeom prst="rect">
@@ -7111,13 +6917,13 @@
       </p:pic>
       <p:sp>
         <p:nvSpPr>
-          <p:cNvPr id="18" name="Text 12"/>
-          <p:cNvSpPr/>
-          <p:nvPr/>
-        </p:nvSpPr>
-        <p:spPr>
-          <a:xfrm>
-            <a:off x="1417320" y="3154680"/>
+          <p:cNvPr id="10" name="Text 6"/>
+          <p:cNvSpPr/>
+          <p:nvPr/>
+        </p:nvSpPr>
+        <p:spPr>
+          <a:xfrm>
+            <a:off x="1417320" y="1965960"/>
             <a:ext cx="3200400" cy="502920"/>
           </a:xfrm>
           <a:prstGeom prst="rect">
@@ -7130,7 +6936,7 @@
           <a:bodyPr wrap="square" lIns="0" tIns="0" rIns="0" bIns="0" rtlCol="0" anchor="ctr"/>
           <a:lstStyle/>
           <a:p>
-            <a:pPr indent="0" marL="0">
+            <a:pPr marL="0" indent="0">
               <a:buNone/>
             </a:pPr>
             <a:r>
@@ -7142,7 +6948,7 @@
                 <a:ea typeface="Trebuchet MS" pitchFamily="34" charset="-122"/>
                 <a:cs typeface="Trebuchet MS" pitchFamily="34" charset="-120"/>
               </a:rPr>
-              <a:t>Context API</a:t>
+              <a:t>useState – Recap &amp; Grenzen</a:t>
             </a:r>
             <a:endParaRPr lang="en-US" sz="1500" dirty="0"/>
           </a:p>
@@ -7150,13 +6956,13 @@
       </p:sp>
       <p:sp>
         <p:nvSpPr>
-          <p:cNvPr id="19" name="Text 13"/>
-          <p:cNvSpPr/>
-          <p:nvPr/>
-        </p:nvSpPr>
-        <p:spPr>
-          <a:xfrm>
-            <a:off x="4754880" y="3154680"/>
+          <p:cNvPr id="11" name="Text 7"/>
+          <p:cNvSpPr/>
+          <p:nvPr/>
+        </p:nvSpPr>
+        <p:spPr>
+          <a:xfrm>
+            <a:off x="4754880" y="1965960"/>
             <a:ext cx="3474720" cy="502920"/>
           </a:xfrm>
           <a:prstGeom prst="rect">
@@ -7169,7 +6975,7 @@
           <a:bodyPr wrap="square" lIns="0" tIns="0" rIns="0" bIns="0" rtlCol="0" anchor="ctr"/>
           <a:lstStyle/>
           <a:p>
-            <a:pPr indent="0" marL="0">
+            <a:pPr marL="0" indent="0">
               <a:buNone/>
             </a:pPr>
             <a:r>
@@ -7181,7 +6987,7 @@
                 <a:ea typeface="Calibri" pitchFamily="34" charset="-122"/>
                 <a:cs typeface="Calibri" pitchFamily="34" charset="-120"/>
               </a:rPr>
-              <a:t>State global teilen ohne Props</a:t>
+              <a:t>Wann reicht useState nicht mehr?</a:t>
             </a:r>
             <a:endParaRPr lang="en-US" sz="1300" dirty="0"/>
           </a:p>
@@ -7189,13 +6995,13 @@
       </p:sp>
       <p:sp>
         <p:nvSpPr>
-          <p:cNvPr id="20" name="Shape 14"/>
-          <p:cNvSpPr/>
-          <p:nvPr/>
-        </p:nvSpPr>
-        <p:spPr>
-          <a:xfrm>
-            <a:off x="731520" y="3749040"/>
+          <p:cNvPr id="12" name="Shape 8"/>
+          <p:cNvSpPr/>
+          <p:nvPr/>
+        </p:nvSpPr>
+        <p:spPr>
+          <a:xfrm>
+            <a:off x="731520" y="2560320"/>
             <a:ext cx="7680960" cy="502920"/>
           </a:xfrm>
           <a:prstGeom prst="roundRect">
@@ -7208,10 +7014,17 @@
           </a:solidFill>
           <a:ln/>
         </p:spPr>
+        <p:txBody>
+          <a:bodyPr/>
+          <a:lstStyle/>
+          <a:p>
+            <a:endParaRPr lang="en-US"/>
+          </a:p>
+        </p:txBody>
       </p:sp>
       <p:pic>
         <p:nvPicPr>
-          <p:cNvPr id="21" name="Image 4" descr="preencoded.png">    </p:cNvPr>
+          <p:cNvPr id="13" name="Image 2" descr="preencoded.png"/>
           <p:cNvPicPr>
             <a:picLocks noChangeAspect="1"/>
           </p:cNvPicPr>
@@ -7225,7 +7038,7 @@
         </p:blipFill>
         <p:spPr>
           <a:xfrm>
-            <a:off x="914400" y="3840480"/>
+            <a:off x="914400" y="2651760"/>
             <a:ext cx="320040" cy="320040"/>
           </a:xfrm>
           <a:prstGeom prst="rect">
@@ -7235,13 +7048,13 @@
       </p:pic>
       <p:sp>
         <p:nvSpPr>
-          <p:cNvPr id="22" name="Text 15"/>
-          <p:cNvSpPr/>
-          <p:nvPr/>
-        </p:nvSpPr>
-        <p:spPr>
-          <a:xfrm>
-            <a:off x="1417320" y="3749040"/>
+          <p:cNvPr id="14" name="Text 9"/>
+          <p:cNvSpPr/>
+          <p:nvPr/>
+        </p:nvSpPr>
+        <p:spPr>
+          <a:xfrm>
+            <a:off x="1417320" y="2560320"/>
             <a:ext cx="3200400" cy="502920"/>
           </a:xfrm>
           <a:prstGeom prst="rect">
@@ -7254,7 +7067,7 @@
           <a:bodyPr wrap="square" lIns="0" tIns="0" rIns="0" bIns="0" rtlCol="0" anchor="ctr"/>
           <a:lstStyle/>
           <a:p>
-            <a:pPr indent="0" marL="0">
+            <a:pPr marL="0" indent="0">
               <a:buNone/>
             </a:pPr>
             <a:r>
@@ -7266,7 +7079,7 @@
                 <a:ea typeface="Trebuchet MS" pitchFamily="34" charset="-122"/>
                 <a:cs typeface="Trebuchet MS" pitchFamily="34" charset="-120"/>
               </a:rPr>
-              <a:t>Externe Libraries</a:t>
+              <a:t>useReducer</a:t>
             </a:r>
             <a:endParaRPr lang="en-US" sz="1500" dirty="0"/>
           </a:p>
@@ -7274,13 +7087,13 @@
       </p:sp>
       <p:sp>
         <p:nvSpPr>
-          <p:cNvPr id="23" name="Text 16"/>
-          <p:cNvSpPr/>
-          <p:nvPr/>
-        </p:nvSpPr>
-        <p:spPr>
-          <a:xfrm>
-            <a:off x="4754880" y="3749040"/>
+          <p:cNvPr id="15" name="Text 10"/>
+          <p:cNvSpPr/>
+          <p:nvPr/>
+        </p:nvSpPr>
+        <p:spPr>
+          <a:xfrm>
+            <a:off x="4754880" y="2560320"/>
             <a:ext cx="3474720" cy="502920"/>
           </a:xfrm>
           <a:prstGeom prst="rect">
@@ -7293,7 +7106,7 @@
           <a:bodyPr wrap="square" lIns="0" tIns="0" rIns="0" bIns="0" rtlCol="0" anchor="ctr"/>
           <a:lstStyle/>
           <a:p>
-            <a:pPr indent="0" marL="0">
+            <a:pPr marL="0" indent="0">
               <a:buNone/>
             </a:pPr>
             <a:r>
@@ -7305,7 +7118,7 @@
                 <a:ea typeface="Calibri" pitchFamily="34" charset="-122"/>
                 <a:cs typeface="Calibri" pitchFamily="34" charset="-120"/>
               </a:rPr>
-              <a:t>Redux, Zustand &amp; Co.</a:t>
+              <a:t>Komplexen State strukturieren</a:t>
             </a:r>
             <a:endParaRPr lang="en-US" sz="1300" dirty="0"/>
           </a:p>
@@ -7313,13 +7126,13 @@
       </p:sp>
       <p:sp>
         <p:nvSpPr>
-          <p:cNvPr id="24" name="Shape 17"/>
-          <p:cNvSpPr/>
-          <p:nvPr/>
-        </p:nvSpPr>
-        <p:spPr>
-          <a:xfrm>
-            <a:off x="731520" y="4343400"/>
+          <p:cNvPr id="16" name="Shape 11"/>
+          <p:cNvSpPr/>
+          <p:nvPr/>
+        </p:nvSpPr>
+        <p:spPr>
+          <a:xfrm>
+            <a:off x="731520" y="3154680"/>
             <a:ext cx="7680960" cy="502920"/>
           </a:xfrm>
           <a:prstGeom prst="roundRect">
@@ -7332,10 +7145,17 @@
           </a:solidFill>
           <a:ln/>
         </p:spPr>
+        <p:txBody>
+          <a:bodyPr/>
+          <a:lstStyle/>
+          <a:p>
+            <a:endParaRPr lang="en-US"/>
+          </a:p>
+        </p:txBody>
       </p:sp>
       <p:pic>
         <p:nvPicPr>
-          <p:cNvPr id="25" name="Image 5" descr="preencoded.png">    </p:cNvPr>
+          <p:cNvPr id="17" name="Image 3" descr="preencoded.png"/>
           <p:cNvPicPr>
             <a:picLocks noChangeAspect="1"/>
           </p:cNvPicPr>
@@ -7349,7 +7169,7 @@
         </p:blipFill>
         <p:spPr>
           <a:xfrm>
-            <a:off x="914400" y="4434840"/>
+            <a:off x="914400" y="3246120"/>
             <a:ext cx="320040" cy="320040"/>
           </a:xfrm>
           <a:prstGeom prst="rect">
@@ -7359,13 +7179,13 @@
       </p:pic>
       <p:sp>
         <p:nvSpPr>
-          <p:cNvPr id="26" name="Text 18"/>
-          <p:cNvSpPr/>
-          <p:nvPr/>
-        </p:nvSpPr>
-        <p:spPr>
-          <a:xfrm>
-            <a:off x="1417320" y="4343400"/>
+          <p:cNvPr id="18" name="Text 12"/>
+          <p:cNvSpPr/>
+          <p:nvPr/>
+        </p:nvSpPr>
+        <p:spPr>
+          <a:xfrm>
+            <a:off x="1417320" y="3154680"/>
             <a:ext cx="3200400" cy="502920"/>
           </a:xfrm>
           <a:prstGeom prst="rect">
@@ -7378,7 +7198,7 @@
           <a:bodyPr wrap="square" lIns="0" tIns="0" rIns="0" bIns="0" rtlCol="0" anchor="ctr"/>
           <a:lstStyle/>
           <a:p>
-            <a:pPr indent="0" marL="0">
+            <a:pPr marL="0" indent="0">
               <a:buNone/>
             </a:pPr>
             <a:r>
@@ -7390,6 +7210,268 @@
                 <a:ea typeface="Trebuchet MS" pitchFamily="34" charset="-122"/>
                 <a:cs typeface="Trebuchet MS" pitchFamily="34" charset="-120"/>
               </a:rPr>
+              <a:t>Context API</a:t>
+            </a:r>
+            <a:endParaRPr lang="en-US" sz="1500" dirty="0"/>
+          </a:p>
+        </p:txBody>
+      </p:sp>
+      <p:sp>
+        <p:nvSpPr>
+          <p:cNvPr id="19" name="Text 13"/>
+          <p:cNvSpPr/>
+          <p:nvPr/>
+        </p:nvSpPr>
+        <p:spPr>
+          <a:xfrm>
+            <a:off x="4754880" y="3154680"/>
+            <a:ext cx="3474720" cy="502920"/>
+          </a:xfrm>
+          <a:prstGeom prst="rect">
+            <a:avLst/>
+          </a:prstGeom>
+          <a:noFill/>
+          <a:ln/>
+        </p:spPr>
+        <p:txBody>
+          <a:bodyPr wrap="square" lIns="0" tIns="0" rIns="0" bIns="0" rtlCol="0" anchor="ctr"/>
+          <a:lstStyle/>
+          <a:p>
+            <a:pPr marL="0" indent="0">
+              <a:buNone/>
+            </a:pPr>
+            <a:r>
+              <a:rPr lang="en-US" sz="1300" dirty="0">
+                <a:solidFill>
+                  <a:srgbClr val="94A3B8"/>
+                </a:solidFill>
+                <a:latin typeface="Calibri" pitchFamily="34" charset="0"/>
+                <a:ea typeface="Calibri" pitchFamily="34" charset="-122"/>
+                <a:cs typeface="Calibri" pitchFamily="34" charset="-120"/>
+              </a:rPr>
+              <a:t>State global teilen ohne Props</a:t>
+            </a:r>
+            <a:endParaRPr lang="en-US" sz="1300" dirty="0"/>
+          </a:p>
+        </p:txBody>
+      </p:sp>
+      <p:sp>
+        <p:nvSpPr>
+          <p:cNvPr id="20" name="Shape 14"/>
+          <p:cNvSpPr/>
+          <p:nvPr/>
+        </p:nvSpPr>
+        <p:spPr>
+          <a:xfrm>
+            <a:off x="731520" y="3749040"/>
+            <a:ext cx="7680960" cy="502920"/>
+          </a:xfrm>
+          <a:prstGeom prst="roundRect">
+            <a:avLst>
+              <a:gd name="adj" fmla="val 9091"/>
+            </a:avLst>
+          </a:prstGeom>
+          <a:solidFill>
+            <a:srgbClr val="1A2744"/>
+          </a:solidFill>
+          <a:ln/>
+        </p:spPr>
+        <p:txBody>
+          <a:bodyPr/>
+          <a:lstStyle/>
+          <a:p>
+            <a:endParaRPr lang="en-US"/>
+          </a:p>
+        </p:txBody>
+      </p:sp>
+      <p:pic>
+        <p:nvPicPr>
+          <p:cNvPr id="21" name="Image 4" descr="preencoded.png"/>
+          <p:cNvPicPr>
+            <a:picLocks noChangeAspect="1"/>
+          </p:cNvPicPr>
+          <p:nvPr/>
+        </p:nvPicPr>
+        <p:blipFill>
+          <a:blip r:embed="rId7"/>
+          <a:stretch>
+            <a:fillRect/>
+          </a:stretch>
+        </p:blipFill>
+        <p:spPr>
+          <a:xfrm>
+            <a:off x="914400" y="3840480"/>
+            <a:ext cx="320040" cy="320040"/>
+          </a:xfrm>
+          <a:prstGeom prst="rect">
+            <a:avLst/>
+          </a:prstGeom>
+        </p:spPr>
+      </p:pic>
+      <p:sp>
+        <p:nvSpPr>
+          <p:cNvPr id="22" name="Text 15"/>
+          <p:cNvSpPr/>
+          <p:nvPr/>
+        </p:nvSpPr>
+        <p:spPr>
+          <a:xfrm>
+            <a:off x="1417320" y="3749040"/>
+            <a:ext cx="3200400" cy="502920"/>
+          </a:xfrm>
+          <a:prstGeom prst="rect">
+            <a:avLst/>
+          </a:prstGeom>
+          <a:noFill/>
+          <a:ln/>
+        </p:spPr>
+        <p:txBody>
+          <a:bodyPr wrap="square" lIns="0" tIns="0" rIns="0" bIns="0" rtlCol="0" anchor="ctr"/>
+          <a:lstStyle/>
+          <a:p>
+            <a:pPr marL="0" indent="0">
+              <a:buNone/>
+            </a:pPr>
+            <a:r>
+              <a:rPr lang="en-US" sz="1500" b="1" dirty="0">
+                <a:solidFill>
+                  <a:srgbClr val="F8FAFC"/>
+                </a:solidFill>
+                <a:latin typeface="Trebuchet MS" pitchFamily="34" charset="0"/>
+                <a:ea typeface="Trebuchet MS" pitchFamily="34" charset="-122"/>
+                <a:cs typeface="Trebuchet MS" pitchFamily="34" charset="-120"/>
+              </a:rPr>
+              <a:t>Externe Libraries</a:t>
+            </a:r>
+            <a:endParaRPr lang="en-US" sz="1500" dirty="0"/>
+          </a:p>
+        </p:txBody>
+      </p:sp>
+      <p:sp>
+        <p:nvSpPr>
+          <p:cNvPr id="23" name="Text 16"/>
+          <p:cNvSpPr/>
+          <p:nvPr/>
+        </p:nvSpPr>
+        <p:spPr>
+          <a:xfrm>
+            <a:off x="4754880" y="3749040"/>
+            <a:ext cx="3474720" cy="502920"/>
+          </a:xfrm>
+          <a:prstGeom prst="rect">
+            <a:avLst/>
+          </a:prstGeom>
+          <a:noFill/>
+          <a:ln/>
+        </p:spPr>
+        <p:txBody>
+          <a:bodyPr wrap="square" lIns="0" tIns="0" rIns="0" bIns="0" rtlCol="0" anchor="ctr"/>
+          <a:lstStyle/>
+          <a:p>
+            <a:pPr marL="0" indent="0">
+              <a:buNone/>
+            </a:pPr>
+            <a:r>
+              <a:rPr lang="en-US" sz="1300" dirty="0">
+                <a:solidFill>
+                  <a:srgbClr val="94A3B8"/>
+                </a:solidFill>
+                <a:latin typeface="Calibri" pitchFamily="34" charset="0"/>
+                <a:ea typeface="Calibri" pitchFamily="34" charset="-122"/>
+                <a:cs typeface="Calibri" pitchFamily="34" charset="-120"/>
+              </a:rPr>
+              <a:t>Redux, Zustand &amp; Co.</a:t>
+            </a:r>
+            <a:endParaRPr lang="en-US" sz="1300" dirty="0"/>
+          </a:p>
+        </p:txBody>
+      </p:sp>
+      <p:sp>
+        <p:nvSpPr>
+          <p:cNvPr id="24" name="Shape 17"/>
+          <p:cNvSpPr/>
+          <p:nvPr/>
+        </p:nvSpPr>
+        <p:spPr>
+          <a:xfrm>
+            <a:off x="731520" y="4343400"/>
+            <a:ext cx="7680960" cy="502920"/>
+          </a:xfrm>
+          <a:prstGeom prst="roundRect">
+            <a:avLst>
+              <a:gd name="adj" fmla="val 9091"/>
+            </a:avLst>
+          </a:prstGeom>
+          <a:solidFill>
+            <a:srgbClr val="1A2744"/>
+          </a:solidFill>
+          <a:ln/>
+        </p:spPr>
+        <p:txBody>
+          <a:bodyPr/>
+          <a:lstStyle/>
+          <a:p>
+            <a:endParaRPr lang="en-US"/>
+          </a:p>
+        </p:txBody>
+      </p:sp>
+      <p:pic>
+        <p:nvPicPr>
+          <p:cNvPr id="25" name="Image 5" descr="preencoded.png"/>
+          <p:cNvPicPr>
+            <a:picLocks noChangeAspect="1"/>
+          </p:cNvPicPr>
+          <p:nvPr/>
+        </p:nvPicPr>
+        <p:blipFill>
+          <a:blip r:embed="rId8"/>
+          <a:stretch>
+            <a:fillRect/>
+          </a:stretch>
+        </p:blipFill>
+        <p:spPr>
+          <a:xfrm>
+            <a:off x="914400" y="4434840"/>
+            <a:ext cx="320040" cy="320040"/>
+          </a:xfrm>
+          <a:prstGeom prst="rect">
+            <a:avLst/>
+          </a:prstGeom>
+        </p:spPr>
+      </p:pic>
+      <p:sp>
+        <p:nvSpPr>
+          <p:cNvPr id="26" name="Text 18"/>
+          <p:cNvSpPr/>
+          <p:nvPr/>
+        </p:nvSpPr>
+        <p:spPr>
+          <a:xfrm>
+            <a:off x="1417320" y="4343400"/>
+            <a:ext cx="3200400" cy="502920"/>
+          </a:xfrm>
+          <a:prstGeom prst="rect">
+            <a:avLst/>
+          </a:prstGeom>
+          <a:noFill/>
+          <a:ln/>
+        </p:spPr>
+        <p:txBody>
+          <a:bodyPr wrap="square" lIns="0" tIns="0" rIns="0" bIns="0" rtlCol="0" anchor="ctr"/>
+          <a:lstStyle/>
+          <a:p>
+            <a:pPr marL="0" indent="0">
+              <a:buNone/>
+            </a:pPr>
+            <a:r>
+              <a:rPr lang="en-US" sz="1500" b="1" dirty="0">
+                <a:solidFill>
+                  <a:srgbClr val="F8FAFC"/>
+                </a:solidFill>
+                <a:latin typeface="Trebuchet MS" pitchFamily="34" charset="0"/>
+                <a:ea typeface="Trebuchet MS" pitchFamily="34" charset="-122"/>
+                <a:cs typeface="Trebuchet MS" pitchFamily="34" charset="-120"/>
+              </a:rPr>
               <a:t>Vergleich &amp; Empfehlung</a:t>
             </a:r>
             <a:endParaRPr lang="en-US" sz="1500" dirty="0"/>
@@ -7417,7 +7499,7 @@
           <a:bodyPr wrap="square" lIns="0" tIns="0" rIns="0" bIns="0" rtlCol="0" anchor="ctr"/>
           <a:lstStyle/>
           <a:p>
-            <a:pPr indent="0" marL="0">
+            <a:pPr marL="0" indent="0">
               <a:buNone/>
             </a:pPr>
             <a:r>
@@ -7451,6 +7533,7 @@
         <a:solidFill>
           <a:srgbClr val="0F1729"/>
         </a:solidFill>
+        <a:effectLst/>
       </p:bgPr>
     </p:bg>
     <p:spTree>
@@ -7488,7 +7571,7 @@
           <a:bodyPr wrap="square" lIns="0" tIns="0" rIns="0" bIns="0" rtlCol="0" anchor="ctr"/>
           <a:lstStyle/>
           <a:p>
-            <a:pPr indent="0" marL="0">
+            <a:pPr marL="0" indent="0">
               <a:buNone/>
             </a:pPr>
             <a:r>
@@ -7525,6 +7608,13 @@
           </a:solidFill>
           <a:ln/>
         </p:spPr>
+        <p:txBody>
+          <a:bodyPr/>
+          <a:lstStyle/>
+          <a:p>
+            <a:endParaRPr lang="en-US"/>
+          </a:p>
+        </p:txBody>
       </p:sp>
       <p:sp>
         <p:nvSpPr>
@@ -7547,7 +7637,7 @@
           <a:bodyPr wrap="square" lIns="0" tIns="0" rIns="0" bIns="0" rtlCol="0" anchor="ctr"/>
           <a:lstStyle/>
           <a:p>
-            <a:pPr indent="0" marL="0">
+            <a:pPr marL="0" indent="0">
               <a:buNone/>
             </a:pPr>
             <a:r>
@@ -7692,17 +7782,24 @@
           </a:solidFill>
           <a:ln/>
         </p:spPr>
+        <p:txBody>
+          <a:bodyPr/>
+          <a:lstStyle/>
+          <a:p>
+            <a:endParaRPr lang="en-US"/>
+          </a:p>
+        </p:txBody>
       </p:sp>
       <p:pic>
         <p:nvPicPr>
-          <p:cNvPr id="7" name="Image 0" descr="preencoded.png">    </p:cNvPr>
+          <p:cNvPr id="7" name="Image 0" descr="preencoded.png"/>
           <p:cNvPicPr>
             <a:picLocks noChangeAspect="1"/>
           </p:cNvPicPr>
           <p:nvPr/>
         </p:nvPicPr>
         <p:blipFill>
-          <a:blip r:embed="rId1"/>
+          <a:blip r:embed="rId3"/>
           <a:stretch>
             <a:fillRect/>
           </a:stretch>
@@ -7738,7 +7835,7 @@
           <a:bodyPr wrap="square" lIns="0" tIns="0" rIns="0" bIns="0" rtlCol="0" anchor="ctr"/>
           <a:lstStyle/>
           <a:p>
-            <a:pPr algn="ctr" indent="0" marL="0">
+            <a:pPr marL="0" indent="0" algn="ctr">
               <a:buNone/>
             </a:pPr>
             <a:r>
@@ -7777,7 +7874,7 @@
           <a:bodyPr wrap="square" lIns="0" tIns="0" rIns="0" bIns="0" rtlCol="0" anchor="ctr"/>
           <a:lstStyle/>
           <a:p>
-            <a:pPr algn="ctr" indent="0" marL="0">
+            <a:pPr marL="0" indent="0" algn="ctr">
               <a:buNone/>
             </a:pPr>
             <a:r>
@@ -7811,6 +7908,7 @@
         <a:solidFill>
           <a:srgbClr val="0F1729"/>
         </a:solidFill>
+        <a:effectLst/>
       </p:bgPr>
     </p:bg>
     <p:spTree>
@@ -7848,7 +7946,7 @@
           <a:bodyPr wrap="square" lIns="0" tIns="0" rIns="0" bIns="0" rtlCol="0" anchor="ctr"/>
           <a:lstStyle/>
           <a:p>
-            <a:pPr indent="0" marL="0">
+            <a:pPr marL="0" indent="0">
               <a:buNone/>
             </a:pPr>
             <a:r>
@@ -7885,6 +7983,13 @@
           </a:solidFill>
           <a:ln/>
         </p:spPr>
+        <p:txBody>
+          <a:bodyPr/>
+          <a:lstStyle/>
+          <a:p>
+            <a:endParaRPr lang="en-US"/>
+          </a:p>
+        </p:txBody>
       </p:sp>
       <p:sp>
         <p:nvSpPr>
@@ -7907,7 +8012,7 @@
           <a:bodyPr wrap="square" lIns="0" tIns="0" rIns="0" bIns="0" rtlCol="0" anchor="ctr"/>
           <a:lstStyle/>
           <a:p>
-            <a:pPr indent="0" marL="0">
+            <a:pPr marL="0" indent="0">
               <a:buNone/>
             </a:pPr>
             <a:r>
@@ -7946,6 +8051,13 @@
           </a:solidFill>
           <a:ln/>
         </p:spPr>
+        <p:txBody>
+          <a:bodyPr/>
+          <a:lstStyle/>
+          <a:p>
+            <a:endParaRPr lang="en-US"/>
+          </a:p>
+        </p:txBody>
       </p:sp>
       <p:sp>
         <p:nvSpPr>
@@ -7968,7 +8080,7 @@
           <a:bodyPr wrap="square" lIns="0" tIns="0" rIns="0" bIns="0" rtlCol="0" anchor="ctr"/>
           <a:lstStyle/>
           <a:p>
-            <a:pPr algn="ctr" indent="0" marL="0">
+            <a:pPr marL="0" indent="0" algn="ctr">
               <a:buNone/>
             </a:pPr>
             <a:r>
@@ -8008,6 +8120,13 @@
             <a:prstDash val="solid"/>
           </a:ln>
         </p:spPr>
+        <p:txBody>
+          <a:bodyPr/>
+          <a:lstStyle/>
+          <a:p>
+            <a:endParaRPr lang="en-US"/>
+          </a:p>
+        </p:txBody>
       </p:sp>
       <p:sp>
         <p:nvSpPr>
@@ -8030,6 +8149,13 @@
           </a:solidFill>
           <a:ln/>
         </p:spPr>
+        <p:txBody>
+          <a:bodyPr/>
+          <a:lstStyle/>
+          <a:p>
+            <a:endParaRPr lang="en-US"/>
+          </a:p>
+        </p:txBody>
       </p:sp>
       <p:sp>
         <p:nvSpPr>
@@ -8052,7 +8178,7 @@
           <a:bodyPr wrap="square" lIns="0" tIns="0" rIns="0" bIns="0" rtlCol="0" anchor="ctr"/>
           <a:lstStyle/>
           <a:p>
-            <a:pPr algn="ctr" indent="0" marL="0">
+            <a:pPr marL="0" indent="0" algn="ctr">
               <a:buNone/>
             </a:pPr>
             <a:r>
@@ -8092,6 +8218,13 @@
             <a:prstDash val="solid"/>
           </a:ln>
         </p:spPr>
+        <p:txBody>
+          <a:bodyPr/>
+          <a:lstStyle/>
+          <a:p>
+            <a:endParaRPr lang="en-US"/>
+          </a:p>
+        </p:txBody>
       </p:sp>
       <p:sp>
         <p:nvSpPr>
@@ -8114,6 +8247,13 @@
           </a:solidFill>
           <a:ln/>
         </p:spPr>
+        <p:txBody>
+          <a:bodyPr/>
+          <a:lstStyle/>
+          <a:p>
+            <a:endParaRPr lang="en-US"/>
+          </a:p>
+        </p:txBody>
       </p:sp>
       <p:sp>
         <p:nvSpPr>
@@ -8136,7 +8276,7 @@
           <a:bodyPr wrap="square" lIns="0" tIns="0" rIns="0" bIns="0" rtlCol="0" anchor="ctr"/>
           <a:lstStyle/>
           <a:p>
-            <a:pPr algn="ctr" indent="0" marL="0">
+            <a:pPr marL="0" indent="0" algn="ctr">
               <a:buNone/>
             </a:pPr>
             <a:r>
@@ -8176,6 +8316,13 @@
             <a:prstDash val="solid"/>
           </a:ln>
         </p:spPr>
+        <p:txBody>
+          <a:bodyPr/>
+          <a:lstStyle/>
+          <a:p>
+            <a:endParaRPr lang="en-US"/>
+          </a:p>
+        </p:txBody>
       </p:sp>
       <p:sp>
         <p:nvSpPr>
@@ -8198,6 +8345,13 @@
           </a:solidFill>
           <a:ln/>
         </p:spPr>
+        <p:txBody>
+          <a:bodyPr/>
+          <a:lstStyle/>
+          <a:p>
+            <a:endParaRPr lang="en-US"/>
+          </a:p>
+        </p:txBody>
       </p:sp>
       <p:sp>
         <p:nvSpPr>
@@ -8220,7 +8374,7 @@
           <a:bodyPr wrap="square" lIns="0" tIns="0" rIns="0" bIns="0" rtlCol="0" anchor="ctr"/>
           <a:lstStyle/>
           <a:p>
-            <a:pPr algn="ctr" indent="0" marL="0">
+            <a:pPr marL="0" indent="0" algn="ctr">
               <a:buNone/>
             </a:pPr>
             <a:r>
@@ -8259,7 +8413,7 @@
           <a:bodyPr wrap="square" lIns="0" tIns="0" rIns="0" bIns="0" rtlCol="0" anchor="ctr"/>
           <a:lstStyle/>
           <a:p>
-            <a:pPr indent="0" marL="0">
+            <a:pPr marL="0" indent="0">
               <a:buNone/>
             </a:pPr>
             <a:r>
@@ -8298,7 +8452,7 @@
           <a:bodyPr wrap="square" lIns="0" tIns="0" rIns="0" bIns="0" rtlCol="0" anchor="ctr"/>
           <a:lstStyle/>
           <a:p>
-            <a:pPr indent="0" marL="0">
+            <a:pPr marL="0" indent="0">
               <a:buNone/>
             </a:pPr>
             <a:r>
@@ -8332,6 +8486,7 @@
         <a:solidFill>
           <a:srgbClr val="0F1729"/>
         </a:solidFill>
+        <a:effectLst/>
       </p:bgPr>
     </p:bg>
     <p:spTree>
@@ -8369,7 +8524,7 @@
           <a:bodyPr wrap="square" lIns="0" tIns="0" rIns="0" bIns="0" rtlCol="0" anchor="ctr"/>
           <a:lstStyle/>
           <a:p>
-            <a:pPr indent="0" marL="0">
+            <a:pPr marL="0" indent="0">
               <a:buNone/>
             </a:pPr>
             <a:r>
@@ -8406,6 +8561,13 @@
           </a:solidFill>
           <a:ln/>
         </p:spPr>
+        <p:txBody>
+          <a:bodyPr/>
+          <a:lstStyle/>
+          <a:p>
+            <a:endParaRPr lang="en-US"/>
+          </a:p>
+        </p:txBody>
       </p:sp>
       <p:sp>
         <p:nvSpPr>
@@ -8428,6 +8590,13 @@
           </a:solidFill>
           <a:ln/>
         </p:spPr>
+        <p:txBody>
+          <a:bodyPr/>
+          <a:lstStyle/>
+          <a:p>
+            <a:endParaRPr lang="en-US"/>
+          </a:p>
+        </p:txBody>
       </p:sp>
       <p:sp>
         <p:nvSpPr>
@@ -8450,7 +8619,7 @@
           <a:bodyPr wrap="square" rtlCol="0" anchor="t"/>
           <a:lstStyle/>
           <a:p>
-            <a:pPr indent="0" marL="0">
+            <a:pPr marL="0" indent="0">
               <a:buNone/>
             </a:pPr>
             <a:r>
@@ -8467,13 +8636,13 @@
             <a:endParaRPr lang="en-US" sz="1300" dirty="0"/>
           </a:p>
           <a:p>
-            <a:pPr indent="0" marL="0">
+            <a:pPr marL="0" indent="0">
               <a:buNone/>
             </a:pPr>
             <a:endParaRPr lang="en-US" sz="1300" dirty="0"/>
           </a:p>
           <a:p>
-            <a:pPr indent="0" marL="0">
+            <a:pPr marL="0" indent="0">
               <a:buNone/>
             </a:pPr>
             <a:r>
@@ -8490,13 +8659,13 @@
             <a:endParaRPr lang="en-US" sz="1300" dirty="0"/>
           </a:p>
           <a:p>
-            <a:pPr indent="0" marL="0">
+            <a:pPr marL="0" indent="0">
               <a:buNone/>
             </a:pPr>
             <a:endParaRPr lang="en-US" sz="1300" dirty="0"/>
           </a:p>
           <a:p>
-            <a:pPr indent="0" marL="0">
+            <a:pPr marL="0" indent="0">
               <a:buNone/>
             </a:pPr>
             <a:r>
@@ -8513,7 +8682,7 @@
             <a:endParaRPr lang="en-US" sz="1300" dirty="0"/>
           </a:p>
           <a:p>
-            <a:pPr indent="0" marL="0">
+            <a:pPr marL="0" indent="0">
               <a:buNone/>
             </a:pPr>
             <a:r>
@@ -8552,17 +8721,24 @@
           </a:solidFill>
           <a:ln/>
         </p:spPr>
+        <p:txBody>
+          <a:bodyPr/>
+          <a:lstStyle/>
+          <a:p>
+            <a:endParaRPr lang="en-US"/>
+          </a:p>
+        </p:txBody>
       </p:sp>
       <p:pic>
         <p:nvPicPr>
-          <p:cNvPr id="7" name="Image 0" descr="preencoded.png">    </p:cNvPr>
+          <p:cNvPr id="7" name="Image 0" descr="preencoded.png"/>
           <p:cNvPicPr>
             <a:picLocks noChangeAspect="1"/>
           </p:cNvPicPr>
           <p:nvPr/>
         </p:nvPicPr>
         <p:blipFill>
-          <a:blip r:embed="rId1"/>
+          <a:blip r:embed="rId3"/>
           <a:stretch>
             <a:fillRect/>
           </a:stretch>
@@ -8598,7 +8774,7 @@
           <a:bodyPr wrap="square" lIns="0" tIns="0" rIns="0" bIns="0" rtlCol="0" anchor="ctr"/>
           <a:lstStyle/>
           <a:p>
-            <a:pPr indent="0" marL="0">
+            <a:pPr marL="0" indent="0">
               <a:buNone/>
             </a:pPr>
             <a:r>
@@ -8695,6 +8871,13 @@
           </a:solidFill>
           <a:ln/>
         </p:spPr>
+        <p:txBody>
+          <a:bodyPr/>
+          <a:lstStyle/>
+          <a:p>
+            <a:endParaRPr lang="en-US"/>
+          </a:p>
+        </p:txBody>
       </p:sp>
       <p:sp>
         <p:nvSpPr>
@@ -8717,7 +8900,7 @@
           <a:bodyPr wrap="square" lIns="0" tIns="0" rIns="0" bIns="0" rtlCol="0" anchor="ctr"/>
           <a:lstStyle/>
           <a:p>
-            <a:pPr indent="0" marL="0">
+            <a:pPr marL="0" indent="0">
               <a:buNone/>
             </a:pPr>
             <a:r>
@@ -8827,6 +9010,7 @@
         <a:solidFill>
           <a:srgbClr val="0F1729"/>
         </a:solidFill>
+        <a:effectLst/>
       </p:bgPr>
     </p:bg>
     <p:spTree>
@@ -8864,7 +9048,7 @@
           <a:bodyPr wrap="square" lIns="0" tIns="0" rIns="0" bIns="0" rtlCol="0" anchor="ctr"/>
           <a:lstStyle/>
           <a:p>
-            <a:pPr indent="0" marL="0">
+            <a:pPr marL="0" indent="0">
               <a:buNone/>
             </a:pPr>
             <a:r>
@@ -8901,6 +9085,13 @@
           </a:solidFill>
           <a:ln/>
         </p:spPr>
+        <p:txBody>
+          <a:bodyPr/>
+          <a:lstStyle/>
+          <a:p>
+            <a:endParaRPr lang="en-US"/>
+          </a:p>
+        </p:txBody>
       </p:sp>
       <p:sp>
         <p:nvSpPr>
@@ -8923,6 +9114,13 @@
           </a:solidFill>
           <a:ln/>
         </p:spPr>
+        <p:txBody>
+          <a:bodyPr/>
+          <a:lstStyle/>
+          <a:p>
+            <a:endParaRPr lang="en-US"/>
+          </a:p>
+        </p:txBody>
       </p:sp>
       <p:sp>
         <p:nvSpPr>
@@ -8945,7 +9143,7 @@
           <a:bodyPr wrap="square" rtlCol="0" anchor="t"/>
           <a:lstStyle/>
           <a:p>
-            <a:pPr indent="0" marL="0">
+            <a:pPr marL="0" indent="0">
               <a:buNone/>
             </a:pPr>
             <a:r>
@@ -8962,7 +9160,7 @@
             <a:endParaRPr lang="en-US" sz="1200" dirty="0"/>
           </a:p>
           <a:p>
-            <a:pPr indent="0" marL="0">
+            <a:pPr marL="0" indent="0">
               <a:buNone/>
             </a:pPr>
             <a:r>
@@ -8979,7 +9177,7 @@
             <a:endParaRPr lang="en-US" sz="1200" dirty="0"/>
           </a:p>
           <a:p>
-            <a:pPr indent="0" marL="0">
+            <a:pPr marL="0" indent="0">
               <a:buNone/>
             </a:pPr>
             <a:r>
@@ -8996,7 +9194,7 @@
             <a:endParaRPr lang="en-US" sz="1200" dirty="0"/>
           </a:p>
           <a:p>
-            <a:pPr indent="0" marL="0">
+            <a:pPr marL="0" indent="0">
               <a:buNone/>
             </a:pPr>
             <a:r>
@@ -9013,13 +9211,13 @@
             <a:endParaRPr lang="en-US" sz="1200" dirty="0"/>
           </a:p>
           <a:p>
-            <a:pPr indent="0" marL="0">
+            <a:pPr marL="0" indent="0">
               <a:buNone/>
             </a:pPr>
             <a:endParaRPr lang="en-US" sz="1200" dirty="0"/>
           </a:p>
           <a:p>
-            <a:pPr indent="0" marL="0">
+            <a:pPr marL="0" indent="0">
               <a:buNone/>
             </a:pPr>
             <a:r>
@@ -9036,7 +9234,7 @@
             <a:endParaRPr lang="en-US" sz="1200" dirty="0"/>
           </a:p>
           <a:p>
-            <a:pPr indent="0" marL="0">
+            <a:pPr marL="0" indent="0">
               <a:buNone/>
             </a:pPr>
             <a:r>
@@ -9053,7 +9251,7 @@
             <a:endParaRPr lang="en-US" sz="1200" dirty="0"/>
           </a:p>
           <a:p>
-            <a:pPr indent="0" marL="0">
+            <a:pPr marL="0" indent="0">
               <a:buNone/>
             </a:pPr>
             <a:r>
@@ -9070,7 +9268,7 @@
             <a:endParaRPr lang="en-US" sz="1200" dirty="0"/>
           </a:p>
           <a:p>
-            <a:pPr indent="0" marL="0">
+            <a:pPr marL="0" indent="0">
               <a:buNone/>
             </a:pPr>
             <a:r>
@@ -9087,7 +9285,7 @@
             <a:endParaRPr lang="en-US" sz="1200" dirty="0"/>
           </a:p>
           <a:p>
-            <a:pPr indent="0" marL="0">
+            <a:pPr marL="0" indent="0">
               <a:buNone/>
             </a:pPr>
             <a:r>
@@ -9104,7 +9302,7 @@
             <a:endParaRPr lang="en-US" sz="1200" dirty="0"/>
           </a:p>
           <a:p>
-            <a:pPr indent="0" marL="0">
+            <a:pPr marL="0" indent="0">
               <a:buNone/>
             </a:pPr>
             <a:r>
@@ -9121,7 +9319,7 @@
             <a:endParaRPr lang="en-US" sz="1200" dirty="0"/>
           </a:p>
           <a:p>
-            <a:pPr indent="0" marL="0">
+            <a:pPr marL="0" indent="0">
               <a:buNone/>
             </a:pPr>
             <a:r>
@@ -9138,7 +9336,7 @@
             <a:endParaRPr lang="en-US" sz="1200" dirty="0"/>
           </a:p>
           <a:p>
-            <a:pPr indent="0" marL="0">
+            <a:pPr marL="0" indent="0">
               <a:buNone/>
             </a:pPr>
             <a:r>
@@ -9172,6 +9370,7 @@
         <a:solidFill>
           <a:srgbClr val="0F1729"/>
         </a:solidFill>
+        <a:effectLst/>
       </p:bgPr>
     </p:bg>
     <p:spTree>
@@ -9209,7 +9408,7 @@
           <a:bodyPr wrap="square" lIns="0" tIns="0" rIns="0" bIns="0" rtlCol="0" anchor="ctr"/>
           <a:lstStyle/>
           <a:p>
-            <a:pPr indent="0" marL="0">
+            <a:pPr marL="0" indent="0">
               <a:buNone/>
             </a:pPr>
             <a:r>
@@ -9246,6 +9445,13 @@
           </a:solidFill>
           <a:ln/>
         </p:spPr>
+        <p:txBody>
+          <a:bodyPr/>
+          <a:lstStyle/>
+          <a:p>
+            <a:endParaRPr lang="en-US"/>
+          </a:p>
+        </p:txBody>
       </p:sp>
       <p:sp>
         <p:nvSpPr>
@@ -9268,6 +9474,13 @@
           </a:solidFill>
           <a:ln/>
         </p:spPr>
+        <p:txBody>
+          <a:bodyPr/>
+          <a:lstStyle/>
+          <a:p>
+            <a:endParaRPr lang="en-US"/>
+          </a:p>
+        </p:txBody>
       </p:sp>
       <p:sp>
         <p:nvSpPr>
@@ -9290,7 +9503,7 @@
           <a:bodyPr wrap="square" lIns="0" tIns="0" rIns="0" bIns="0" rtlCol="0" anchor="ctr"/>
           <a:lstStyle/>
           <a:p>
-            <a:pPr algn="ctr" indent="0" marL="0">
+            <a:pPr marL="0" indent="0" algn="ctr">
               <a:buNone/>
             </a:pPr>
             <a:r>
@@ -9329,7 +9542,7 @@
           <a:bodyPr wrap="square" lIns="0" tIns="0" rIns="0" bIns="0" rtlCol="0" anchor="ctr"/>
           <a:lstStyle/>
           <a:p>
-            <a:pPr algn="ctr" indent="0" marL="0">
+            <a:pPr marL="0" indent="0" algn="ctr">
               <a:buNone/>
             </a:pPr>
             <a:r>
@@ -9346,7 +9559,7 @@
             <a:endParaRPr lang="en-US" sz="1200" dirty="0"/>
           </a:p>
           <a:p>
-            <a:pPr algn="ctr" indent="0" marL="0">
+            <a:pPr marL="0" indent="0" algn="ctr">
               <a:buNone/>
             </a:pPr>
             <a:r>
@@ -9385,6 +9598,13 @@
           </a:solidFill>
           <a:ln/>
         </p:spPr>
+        <p:txBody>
+          <a:bodyPr/>
+          <a:lstStyle/>
+          <a:p>
+            <a:endParaRPr lang="en-US"/>
+          </a:p>
+        </p:txBody>
       </p:sp>
       <p:sp>
         <p:nvSpPr>
@@ -9407,7 +9627,7 @@
           <a:bodyPr wrap="square" lIns="0" tIns="0" rIns="0" bIns="0" rtlCol="0" anchor="ctr"/>
           <a:lstStyle/>
           <a:p>
-            <a:pPr algn="ctr" indent="0" marL="0">
+            <a:pPr marL="0" indent="0" algn="ctr">
               <a:buNone/>
             </a:pPr>
             <a:r>
@@ -9446,7 +9666,7 @@
           <a:bodyPr wrap="square" lIns="0" tIns="0" rIns="0" bIns="0" rtlCol="0" anchor="ctr"/>
           <a:lstStyle/>
           <a:p>
-            <a:pPr algn="ctr" indent="0" marL="0">
+            <a:pPr marL="0" indent="0" algn="ctr">
               <a:buNone/>
             </a:pPr>
             <a:r>
@@ -9463,7 +9683,7 @@
             <a:endParaRPr lang="en-US" sz="1200" dirty="0"/>
           </a:p>
           <a:p>
-            <a:pPr algn="ctr" indent="0" marL="0">
+            <a:pPr marL="0" indent="0" algn="ctr">
               <a:buNone/>
             </a:pPr>
             <a:r>
@@ -9502,6 +9722,13 @@
           </a:solidFill>
           <a:ln/>
         </p:spPr>
+        <p:txBody>
+          <a:bodyPr/>
+          <a:lstStyle/>
+          <a:p>
+            <a:endParaRPr lang="en-US"/>
+          </a:p>
+        </p:txBody>
       </p:sp>
       <p:sp>
         <p:nvSpPr>
@@ -9524,7 +9751,7 @@
           <a:bodyPr wrap="square" lIns="0" tIns="0" rIns="0" bIns="0" rtlCol="0" anchor="ctr"/>
           <a:lstStyle/>
           <a:p>
-            <a:pPr algn="ctr" indent="0" marL="0">
+            <a:pPr marL="0" indent="0" algn="ctr">
               <a:buNone/>
             </a:pPr>
             <a:r>
@@ -9563,7 +9790,7 @@
           <a:bodyPr wrap="square" lIns="0" tIns="0" rIns="0" bIns="0" rtlCol="0" anchor="ctr"/>
           <a:lstStyle/>
           <a:p>
-            <a:pPr algn="ctr" indent="0" marL="0">
+            <a:pPr marL="0" indent="0" algn="ctr">
               <a:buNone/>
             </a:pPr>
             <a:r>
@@ -9580,7 +9807,7 @@
             <a:endParaRPr lang="en-US" sz="1200" dirty="0"/>
           </a:p>
           <a:p>
-            <a:pPr algn="ctr" indent="0" marL="0">
+            <a:pPr marL="0" indent="0" algn="ctr">
               <a:buNone/>
             </a:pPr>
             <a:r>
@@ -9600,14 +9827,14 @@
       </p:sp>
       <p:pic>
         <p:nvPicPr>
-          <p:cNvPr id="13" name="Image 0" descr="preencoded.png">    </p:cNvPr>
+          <p:cNvPr id="13" name="Image 0" descr="preencoded.png"/>
           <p:cNvPicPr>
             <a:picLocks noChangeAspect="1"/>
           </p:cNvPicPr>
           <p:nvPr/>
         </p:nvPicPr>
         <p:blipFill>
-          <a:blip r:embed="rId1"/>
+          <a:blip r:embed="rId3"/>
           <a:stretch>
             <a:fillRect/>
           </a:stretch>
@@ -9624,14 +9851,14 @@
       </p:pic>
       <p:pic>
         <p:nvPicPr>
-          <p:cNvPr id="14" name="Image 1" descr="preencoded.png">    </p:cNvPr>
+          <p:cNvPr id="14" name="Image 1" descr="preencoded.png"/>
           <p:cNvPicPr>
             <a:picLocks noChangeAspect="1"/>
           </p:cNvPicPr>
           <p:nvPr/>
         </p:nvPicPr>
         <p:blipFill>
-          <a:blip r:embed="rId2"/>
+          <a:blip r:embed="rId3"/>
           <a:stretch>
             <a:fillRect/>
           </a:stretch>
@@ -9667,6 +9894,13 @@
           </a:solidFill>
           <a:ln/>
         </p:spPr>
+        <p:txBody>
+          <a:bodyPr/>
+          <a:lstStyle/>
+          <a:p>
+            <a:endParaRPr lang="en-US"/>
+          </a:p>
+        </p:txBody>
       </p:sp>
       <p:sp>
         <p:nvSpPr>
@@ -9689,7 +9923,7 @@
           <a:bodyPr wrap="square" rtlCol="0" anchor="t"/>
           <a:lstStyle/>
           <a:p>
-            <a:pPr indent="0" marL="0">
+            <a:pPr marL="0" indent="0">
               <a:buNone/>
             </a:pPr>
             <a:r>
@@ -9706,13 +9940,13 @@
             <a:endParaRPr lang="en-US" sz="1300" dirty="0"/>
           </a:p>
           <a:p>
-            <a:pPr indent="0" marL="0">
+            <a:pPr marL="0" indent="0">
               <a:buNone/>
             </a:pPr>
             <a:endParaRPr lang="en-US" sz="1300" dirty="0"/>
           </a:p>
           <a:p>
-            <a:pPr indent="0" marL="0">
+            <a:pPr marL="0" indent="0">
               <a:buNone/>
             </a:pPr>
             <a:r>
@@ -9729,7 +9963,7 @@
             <a:endParaRPr lang="en-US" sz="1300" dirty="0"/>
           </a:p>
           <a:p>
-            <a:pPr indent="0" marL="0">
+            <a:pPr marL="0" indent="0">
               <a:buNone/>
             </a:pPr>
             <a:r>
@@ -9746,7 +9980,7 @@
             <a:endParaRPr lang="en-US" sz="1300" dirty="0"/>
           </a:p>
           <a:p>
-            <a:pPr indent="0" marL="0">
+            <a:pPr marL="0" indent="0">
               <a:buNone/>
             </a:pPr>
             <a:r>
@@ -9780,6 +10014,7 @@
         <a:solidFill>
           <a:srgbClr val="0F1729"/>
         </a:solidFill>
+        <a:effectLst/>
       </p:bgPr>
     </p:bg>
     <p:spTree>
@@ -9817,7 +10052,7 @@
           <a:bodyPr wrap="square" lIns="0" tIns="0" rIns="0" bIns="0" rtlCol="0" anchor="ctr"/>
           <a:lstStyle/>
           <a:p>
-            <a:pPr indent="0" marL="0">
+            <a:pPr marL="0" indent="0">
               <a:buNone/>
             </a:pPr>
             <a:r>
@@ -9854,6 +10089,13 @@
           </a:solidFill>
           <a:ln/>
         </p:spPr>
+        <p:txBody>
+          <a:bodyPr/>
+          <a:lstStyle/>
+          <a:p>
+            <a:endParaRPr lang="en-US"/>
+          </a:p>
+        </p:txBody>
       </p:sp>
       <p:sp>
         <p:nvSpPr>
@@ -9876,6 +10118,13 @@
           </a:solidFill>
           <a:ln/>
         </p:spPr>
+        <p:txBody>
+          <a:bodyPr/>
+          <a:lstStyle/>
+          <a:p>
+            <a:endParaRPr lang="en-US"/>
+          </a:p>
+        </p:txBody>
       </p:sp>
       <p:sp>
         <p:nvSpPr>
@@ -9898,7 +10147,7 @@
           <a:bodyPr wrap="square" rtlCol="0" anchor="t"/>
           <a:lstStyle/>
           <a:p>
-            <a:pPr indent="0" marL="0">
+            <a:pPr marL="0" indent="0">
               <a:buNone/>
             </a:pPr>
             <a:r>
@@ -9915,7 +10164,7 @@
             <a:endParaRPr lang="en-US" sz="1100" dirty="0"/>
           </a:p>
           <a:p>
-            <a:pPr indent="0" marL="0">
+            <a:pPr marL="0" indent="0">
               <a:buNone/>
             </a:pPr>
             <a:r>
@@ -9932,7 +10181,7 @@
             <a:endParaRPr lang="en-US" sz="1100" dirty="0"/>
           </a:p>
           <a:p>
-            <a:pPr indent="0" marL="0">
+            <a:pPr marL="0" indent="0">
               <a:buNone/>
             </a:pPr>
             <a:r>
@@ -9949,7 +10198,7 @@
             <a:endParaRPr lang="en-US" sz="1100" dirty="0"/>
           </a:p>
           <a:p>
-            <a:pPr indent="0" marL="0">
+            <a:pPr marL="0" indent="0">
               <a:buNone/>
             </a:pPr>
             <a:r>
@@ -9966,7 +10215,7 @@
             <a:endParaRPr lang="en-US" sz="1100" dirty="0"/>
           </a:p>
           <a:p>
-            <a:pPr indent="0" marL="0">
+            <a:pPr marL="0" indent="0">
               <a:buNone/>
             </a:pPr>
             <a:r>
@@ -9983,7 +10232,7 @@
             <a:endParaRPr lang="en-US" sz="1100" dirty="0"/>
           </a:p>
           <a:p>
-            <a:pPr indent="0" marL="0">
+            <a:pPr marL="0" indent="0">
               <a:buNone/>
             </a:pPr>
             <a:r>
@@ -10000,7 +10249,7 @@
             <a:endParaRPr lang="en-US" sz="1100" dirty="0"/>
           </a:p>
           <a:p>
-            <a:pPr indent="0" marL="0">
+            <a:pPr marL="0" indent="0">
               <a:buNone/>
             </a:pPr>
             <a:r>
@@ -10017,7 +10266,7 @@
             <a:endParaRPr lang="en-US" sz="1100" dirty="0"/>
           </a:p>
           <a:p>
-            <a:pPr indent="0" marL="0">
+            <a:pPr marL="0" indent="0">
               <a:buNone/>
             </a:pPr>
             <a:r>
@@ -10034,7 +10283,7 @@
             <a:endParaRPr lang="en-US" sz="1100" dirty="0"/>
           </a:p>
           <a:p>
-            <a:pPr indent="0" marL="0">
+            <a:pPr marL="0" indent="0">
               <a:buNone/>
             </a:pPr>
             <a:r>
@@ -10051,7 +10300,7 @@
             <a:endParaRPr lang="en-US" sz="1100" dirty="0"/>
           </a:p>
           <a:p>
-            <a:pPr indent="0" marL="0">
+            <a:pPr marL="0" indent="0">
               <a:buNone/>
             </a:pPr>
             <a:r>
@@ -10068,7 +10317,7 @@
             <a:endParaRPr lang="en-US" sz="1100" dirty="0"/>
           </a:p>
           <a:p>
-            <a:pPr indent="0" marL="0">
+            <a:pPr marL="0" indent="0">
               <a:buNone/>
             </a:pPr>
             <a:r>
@@ -10085,13 +10334,13 @@
             <a:endParaRPr lang="en-US" sz="1100" dirty="0"/>
           </a:p>
           <a:p>
-            <a:pPr indent="0" marL="0">
+            <a:pPr marL="0" indent="0">
               <a:buNone/>
             </a:pPr>
             <a:endParaRPr lang="en-US" sz="1100" dirty="0"/>
           </a:p>
           <a:p>
-            <a:pPr indent="0" marL="0">
+            <a:pPr marL="0" indent="0">
               <a:buNone/>
             </a:pPr>
             <a:r>
@@ -10108,7 +10357,7 @@
             <a:endParaRPr lang="en-US" sz="1100" dirty="0"/>
           </a:p>
           <a:p>
-            <a:pPr indent="0" marL="0">
+            <a:pPr marL="0" indent="0">
               <a:buNone/>
             </a:pPr>
             <a:r>
@@ -10142,6 +10391,7 @@
         <a:solidFill>
           <a:srgbClr val="0F1729"/>
         </a:solidFill>
+        <a:effectLst/>
       </p:bgPr>
     </p:bg>
     <p:spTree>
@@ -10179,7 +10429,7 @@
           <a:bodyPr wrap="square" lIns="0" tIns="0" rIns="0" bIns="0" rtlCol="0" anchor="ctr"/>
           <a:lstStyle/>
           <a:p>
-            <a:pPr indent="0" marL="0">
+            <a:pPr marL="0" indent="0">
               <a:buNone/>
             </a:pPr>
             <a:r>
@@ -10191,7 +10441,7 @@
                 <a:ea typeface="Trebuchet MS" pitchFamily="34" charset="-122"/>
                 <a:cs typeface="Trebuchet MS" pitchFamily="34" charset="-120"/>
               </a:rPr>
-              <a:t>Context API</a:t>
+              <a:t>Context</a:t>
             </a:r>
             <a:endParaRPr lang="en-US" sz="3600" dirty="0"/>
           </a:p>
@@ -10216,6 +10466,13 @@
           </a:solidFill>
           <a:ln/>
         </p:spPr>
+        <p:txBody>
+          <a:bodyPr/>
+          <a:lstStyle/>
+          <a:p>
+            <a:endParaRPr lang="en-US"/>
+          </a:p>
+        </p:txBody>
       </p:sp>
       <p:sp>
         <p:nvSpPr>
@@ -10238,7 +10495,7 @@
           <a:bodyPr wrap="square" lIns="0" tIns="0" rIns="0" bIns="0" rtlCol="0" anchor="ctr"/>
           <a:lstStyle/>
           <a:p>
-            <a:pPr indent="0" marL="0">
+            <a:pPr marL="0" indent="0">
               <a:buNone/>
             </a:pPr>
             <a:r>
@@ -10275,6 +10532,13 @@
           </a:solidFill>
           <a:ln/>
         </p:spPr>
+        <p:txBody>
+          <a:bodyPr/>
+          <a:lstStyle/>
+          <a:p>
+            <a:endParaRPr lang="en-US"/>
+          </a:p>
+        </p:txBody>
       </p:sp>
       <p:sp>
         <p:nvSpPr>
@@ -10297,7 +10561,7 @@
           <a:bodyPr wrap="square" lIns="0" tIns="0" rIns="0" bIns="0" rtlCol="0" anchor="ctr"/>
           <a:lstStyle/>
           <a:p>
-            <a:pPr algn="ctr" indent="0" marL="0">
+            <a:pPr marL="0" indent="0" algn="ctr">
               <a:buNone/>
             </a:pPr>
             <a:r>
@@ -10336,7 +10600,7 @@
           <a:bodyPr wrap="square" lIns="0" tIns="0" rIns="0" bIns="0" rtlCol="0" anchor="ctr"/>
           <a:lstStyle/>
           <a:p>
-            <a:pPr indent="0" marL="0">
+            <a:pPr marL="0" indent="0">
               <a:buNone/>
             </a:pPr>
             <a:r>
@@ -10375,6 +10639,13 @@
           </a:solidFill>
           <a:ln/>
         </p:spPr>
+        <p:txBody>
+          <a:bodyPr/>
+          <a:lstStyle/>
+          <a:p>
+            <a:endParaRPr lang="en-US"/>
+          </a:p>
+        </p:txBody>
       </p:sp>
       <p:sp>
         <p:nvSpPr>
@@ -10397,7 +10668,7 @@
           <a:bodyPr wrap="square" lIns="0" tIns="0" rIns="0" bIns="0" rtlCol="0" anchor="ctr"/>
           <a:lstStyle/>
           <a:p>
-            <a:pPr indent="0" marL="0">
+            <a:pPr marL="0" indent="0">
               <a:buNone/>
             </a:pPr>
             <a:r>
@@ -10434,6 +10705,13 @@
           </a:solidFill>
           <a:ln/>
         </p:spPr>
+        <p:txBody>
+          <a:bodyPr/>
+          <a:lstStyle/>
+          <a:p>
+            <a:endParaRPr lang="en-US"/>
+          </a:p>
+        </p:txBody>
       </p:sp>
       <p:sp>
         <p:nvSpPr>
@@ -10456,7 +10734,7 @@
           <a:bodyPr wrap="square" lIns="0" tIns="0" rIns="0" bIns="0" rtlCol="0" anchor="ctr"/>
           <a:lstStyle/>
           <a:p>
-            <a:pPr algn="ctr" indent="0" marL="0">
+            <a:pPr marL="0" indent="0" algn="ctr">
               <a:buNone/>
             </a:pPr>
             <a:r>
@@ -10495,7 +10773,7 @@
           <a:bodyPr wrap="square" lIns="0" tIns="0" rIns="0" bIns="0" rtlCol="0" anchor="ctr"/>
           <a:lstStyle/>
           <a:p>
-            <a:pPr indent="0" marL="0">
+            <a:pPr marL="0" indent="0">
               <a:buNone/>
             </a:pPr>
             <a:r>
@@ -10534,6 +10812,13 @@
           </a:solidFill>
           <a:ln/>
         </p:spPr>
+        <p:txBody>
+          <a:bodyPr/>
+          <a:lstStyle/>
+          <a:p>
+            <a:endParaRPr lang="en-US"/>
+          </a:p>
+        </p:txBody>
       </p:sp>
       <p:sp>
         <p:nvSpPr>
@@ -10556,7 +10841,7 @@
           <a:bodyPr wrap="square" lIns="0" tIns="0" rIns="0" bIns="0" rtlCol="0" anchor="ctr"/>
           <a:lstStyle/>
           <a:p>
-            <a:pPr indent="0" marL="0">
+            <a:pPr marL="0" indent="0">
               <a:buNone/>
             </a:pPr>
             <a:r>
@@ -10573,7 +10858,7 @@
             <a:endParaRPr lang="en-US" sz="1200" dirty="0"/>
           </a:p>
           <a:p>
-            <a:pPr indent="0" marL="0">
+            <a:pPr marL="0" indent="0">
               <a:buNone/>
             </a:pPr>
             <a:r>
@@ -10590,7 +10875,7 @@
             <a:endParaRPr lang="en-US" sz="1200" dirty="0"/>
           </a:p>
           <a:p>
-            <a:pPr indent="0" marL="0">
+            <a:pPr marL="0" indent="0">
               <a:buNone/>
             </a:pPr>
             <a:r>
@@ -10627,6 +10912,13 @@
           </a:solidFill>
           <a:ln/>
         </p:spPr>
+        <p:txBody>
+          <a:bodyPr/>
+          <a:lstStyle/>
+          <a:p>
+            <a:endParaRPr lang="en-US"/>
+          </a:p>
+        </p:txBody>
       </p:sp>
       <p:sp>
         <p:nvSpPr>
@@ -10649,7 +10941,7 @@
           <a:bodyPr wrap="square" lIns="0" tIns="0" rIns="0" bIns="0" rtlCol="0" anchor="ctr"/>
           <a:lstStyle/>
           <a:p>
-            <a:pPr algn="ctr" indent="0" marL="0">
+            <a:pPr marL="0" indent="0" algn="ctr">
               <a:buNone/>
             </a:pPr>
             <a:r>
@@ -10688,7 +10980,7 @@
           <a:bodyPr wrap="square" lIns="0" tIns="0" rIns="0" bIns="0" rtlCol="0" anchor="ctr"/>
           <a:lstStyle/>
           <a:p>
-            <a:pPr indent="0" marL="0">
+            <a:pPr marL="0" indent="0">
               <a:buNone/>
             </a:pPr>
             <a:r>
@@ -10727,6 +11019,13 @@
           </a:solidFill>
           <a:ln/>
         </p:spPr>
+        <p:txBody>
+          <a:bodyPr/>
+          <a:lstStyle/>
+          <a:p>
+            <a:endParaRPr lang="en-US"/>
+          </a:p>
+        </p:txBody>
       </p:sp>
       <p:sp>
         <p:nvSpPr>
@@ -10749,7 +11048,7 @@
           <a:bodyPr wrap="square" lIns="0" tIns="0" rIns="0" bIns="0" rtlCol="0" anchor="ctr"/>
           <a:lstStyle/>
           <a:p>
-            <a:pPr indent="0" marL="0">
+            <a:pPr marL="0" indent="0">
               <a:buNone/>
             </a:pPr>
             <a:r>
@@ -11068,4 +11367,319 @@
     </a:ext>
   </a:extLst>
 </a:theme>
+</file>
+
+<file path=ppt/theme/theme2.xml><?xml version="1.0" encoding="utf-8"?>
+<a:theme xmlns:a="http://schemas.openxmlformats.org/drawingml/2006/main" name="Office Theme">
+  <a:themeElements>
+    <a:clrScheme name="Office">
+      <a:dk1>
+        <a:sysClr val="windowText" lastClr="000000"/>
+      </a:dk1>
+      <a:lt1>
+        <a:sysClr val="window" lastClr="FFFFFF"/>
+      </a:lt1>
+      <a:dk2>
+        <a:srgbClr val="0E2841"/>
+      </a:dk2>
+      <a:lt2>
+        <a:srgbClr val="E8E8E8"/>
+      </a:lt2>
+      <a:accent1>
+        <a:srgbClr val="156082"/>
+      </a:accent1>
+      <a:accent2>
+        <a:srgbClr val="E97132"/>
+      </a:accent2>
+      <a:accent3>
+        <a:srgbClr val="196B24"/>
+      </a:accent3>
+      <a:accent4>
+        <a:srgbClr val="0F9ED5"/>
+      </a:accent4>
+      <a:accent5>
+        <a:srgbClr val="A02B93"/>
+      </a:accent5>
+      <a:accent6>
+        <a:srgbClr val="4EA72E"/>
+      </a:accent6>
+      <a:hlink>
+        <a:srgbClr val="467886"/>
+      </a:hlink>
+      <a:folHlink>
+        <a:srgbClr val="96607D"/>
+      </a:folHlink>
+    </a:clrScheme>
+    <a:fontScheme name="Office">
+      <a:majorFont>
+        <a:latin typeface="Aptos Display" panose="02110004020202020204"/>
+        <a:ea typeface=""/>
+        <a:cs typeface=""/>
+        <a:font script="Jpan" typeface="游ゴシック Light"/>
+        <a:font script="Hang" typeface="맑은 고딕"/>
+        <a:font script="Hans" typeface="等线 Light"/>
+        <a:font script="Hant" typeface="新細明體"/>
+        <a:font script="Arab" typeface="Times New Roman"/>
+        <a:font script="Hebr" typeface="Times New Roman"/>
+        <a:font script="Thai" typeface="Angsana New"/>
+        <a:font script="Ethi" typeface="Nyala"/>
+        <a:font script="Beng" typeface="Vrinda"/>
+        <a:font script="Gujr" typeface="Shruti"/>
+        <a:font script="Khmr" typeface="MoolBoran"/>
+        <a:font script="Knda" typeface="Tunga"/>
+        <a:font script="Guru" typeface="Raavi"/>
+        <a:font script="Cans" typeface="Euphemia"/>
+        <a:font script="Cher" typeface="Plantagenet Cherokee"/>
+        <a:font script="Yiii" typeface="Microsoft Yi Baiti"/>
+        <a:font script="Tibt" typeface="Microsoft Himalaya"/>
+        <a:font script="Thaa" typeface="MV Boli"/>
+        <a:font script="Deva" typeface="Mangal"/>
+        <a:font script="Telu" typeface="Gautami"/>
+        <a:font script="Taml" typeface="Latha"/>
+        <a:font script="Syrc" typeface="Estrangelo Edessa"/>
+        <a:font script="Orya" typeface="Kalinga"/>
+        <a:font script="Mlym" typeface="Kartika"/>
+        <a:font script="Laoo" typeface="DokChampa"/>
+        <a:font script="Sinh" typeface="Iskoola Pota"/>
+        <a:font script="Mong" typeface="Mongolian Baiti"/>
+        <a:font script="Viet" typeface="Times New Roman"/>
+        <a:font script="Uigh" typeface="Microsoft Uighur"/>
+        <a:font script="Geor" typeface="Sylfaen"/>
+        <a:font script="Armn" typeface="Arial"/>
+        <a:font script="Bugi" typeface="Leelawadee UI"/>
+        <a:font script="Bopo" typeface="Microsoft JhengHei"/>
+        <a:font script="Java" typeface="Javanese Text"/>
+        <a:font script="Lisu" typeface="Segoe UI"/>
+        <a:font script="Mymr" typeface="Myanmar Text"/>
+        <a:font script="Nkoo" typeface="Ebrima"/>
+        <a:font script="Olck" typeface="Nirmala UI"/>
+        <a:font script="Osma" typeface="Ebrima"/>
+        <a:font script="Phag" typeface="Phagspa"/>
+        <a:font script="Syrn" typeface="Estrangelo Edessa"/>
+        <a:font script="Syrj" typeface="Estrangelo Edessa"/>
+        <a:font script="Syre" typeface="Estrangelo Edessa"/>
+        <a:font script="Sora" typeface="Nirmala UI"/>
+        <a:font script="Tale" typeface="Microsoft Tai Le"/>
+        <a:font script="Talu" typeface="Microsoft New Tai Lue"/>
+        <a:font script="Tfng" typeface="Ebrima"/>
+      </a:majorFont>
+      <a:minorFont>
+        <a:latin typeface="Aptos" panose="02110004020202020204"/>
+        <a:ea typeface=""/>
+        <a:cs typeface=""/>
+        <a:font script="Jpan" typeface="游ゴシック"/>
+        <a:font script="Hang" typeface="맑은 고딕"/>
+        <a:font script="Hans" typeface="等线"/>
+        <a:font script="Hant" typeface="新細明體"/>
+        <a:font script="Arab" typeface="Arial"/>
+        <a:font script="Hebr" typeface="Arial"/>
+        <a:font script="Thai" typeface="Cordia New"/>
+        <a:font script="Ethi" typeface="Nyala"/>
+        <a:font script="Beng" typeface="Vrinda"/>
+        <a:font script="Gujr" typeface="Shruti"/>
+        <a:font script="Khmr" typeface="DaunPenh"/>
+        <a:font script="Knda" typeface="Tunga"/>
+        <a:font script="Guru" typeface="Raavi"/>
+        <a:font script="Cans" typeface="Euphemia"/>
+        <a:font script="Cher" typeface="Plantagenet Cherokee"/>
+        <a:font script="Yiii" typeface="Microsoft Yi Baiti"/>
+        <a:font script="Tibt" typeface="Microsoft Himalaya"/>
+        <a:font script="Thaa" typeface="MV Boli"/>
+        <a:font script="Deva" typeface="Mangal"/>
+        <a:font script="Telu" typeface="Gautami"/>
+        <a:font script="Taml" typeface="Latha"/>
+        <a:font script="Syrc" typeface="Estrangelo Edessa"/>
+        <a:font script="Orya" typeface="Kalinga"/>
+        <a:font script="Mlym" typeface="Kartika"/>
+        <a:font script="Laoo" typeface="DokChampa"/>
+        <a:font script="Sinh" typeface="Iskoola Pota"/>
+        <a:font script="Mong" typeface="Mongolian Baiti"/>
+        <a:font script="Viet" typeface="Arial"/>
+        <a:font script="Uigh" typeface="Microsoft Uighur"/>
+        <a:font script="Geor" typeface="Sylfaen"/>
+        <a:font script="Armn" typeface="Arial"/>
+        <a:font script="Bugi" typeface="Leelawadee UI"/>
+        <a:font script="Bopo" typeface="Microsoft JhengHei"/>
+        <a:font script="Java" typeface="Javanese Text"/>
+        <a:font script="Lisu" typeface="Segoe UI"/>
+        <a:font script="Mymr" typeface="Myanmar Text"/>
+        <a:font script="Nkoo" typeface="Ebrima"/>
+        <a:font script="Olck" typeface="Nirmala UI"/>
+        <a:font script="Osma" typeface="Ebrima"/>
+        <a:font script="Phag" typeface="Phagspa"/>
+        <a:font script="Syrn" typeface="Estrangelo Edessa"/>
+        <a:font script="Syrj" typeface="Estrangelo Edessa"/>
+        <a:font script="Syre" typeface="Estrangelo Edessa"/>
+        <a:font script="Sora" typeface="Nirmala UI"/>
+        <a:font script="Tale" typeface="Microsoft Tai Le"/>
+        <a:font script="Talu" typeface="Microsoft New Tai Lue"/>
+        <a:font script="Tfng" typeface="Ebrima"/>
+      </a:minorFont>
+    </a:fontScheme>
+    <a:fmtScheme name="Office">
+      <a:fillStyleLst>
+        <a:solidFill>
+          <a:schemeClr val="phClr"/>
+        </a:solidFill>
+        <a:gradFill rotWithShape="1">
+          <a:gsLst>
+            <a:gs pos="0">
+              <a:schemeClr val="phClr">
+                <a:lumMod val="110000"/>
+                <a:satMod val="105000"/>
+                <a:tint val="67000"/>
+              </a:schemeClr>
+            </a:gs>
+            <a:gs pos="50000">
+              <a:schemeClr val="phClr">
+                <a:lumMod val="105000"/>
+                <a:satMod val="103000"/>
+                <a:tint val="73000"/>
+              </a:schemeClr>
+            </a:gs>
+            <a:gs pos="100000">
+              <a:schemeClr val="phClr">
+                <a:lumMod val="105000"/>
+                <a:satMod val="109000"/>
+                <a:tint val="81000"/>
+              </a:schemeClr>
+            </a:gs>
+          </a:gsLst>
+          <a:lin ang="5400000" scaled="0"/>
+        </a:gradFill>
+        <a:gradFill rotWithShape="1">
+          <a:gsLst>
+            <a:gs pos="0">
+              <a:schemeClr val="phClr">
+                <a:satMod val="103000"/>
+                <a:lumMod val="102000"/>
+                <a:tint val="94000"/>
+              </a:schemeClr>
+            </a:gs>
+            <a:gs pos="50000">
+              <a:schemeClr val="phClr">
+                <a:satMod val="110000"/>
+                <a:lumMod val="100000"/>
+                <a:shade val="100000"/>
+              </a:schemeClr>
+            </a:gs>
+            <a:gs pos="100000">
+              <a:schemeClr val="phClr">
+                <a:lumMod val="99000"/>
+                <a:satMod val="120000"/>
+                <a:shade val="78000"/>
+              </a:schemeClr>
+            </a:gs>
+          </a:gsLst>
+          <a:lin ang="5400000" scaled="0"/>
+        </a:gradFill>
+      </a:fillStyleLst>
+      <a:lnStyleLst>
+        <a:ln w="12700" cap="flat" cmpd="sng" algn="ctr">
+          <a:solidFill>
+            <a:schemeClr val="phClr"/>
+          </a:solidFill>
+          <a:prstDash val="solid"/>
+          <a:miter lim="800000"/>
+        </a:ln>
+        <a:ln w="19050" cap="flat" cmpd="sng" algn="ctr">
+          <a:solidFill>
+            <a:schemeClr val="phClr"/>
+          </a:solidFill>
+          <a:prstDash val="solid"/>
+          <a:miter lim="800000"/>
+        </a:ln>
+        <a:ln w="25400" cap="flat" cmpd="sng" algn="ctr">
+          <a:solidFill>
+            <a:schemeClr val="phClr"/>
+          </a:solidFill>
+          <a:prstDash val="solid"/>
+          <a:miter lim="800000"/>
+        </a:ln>
+      </a:lnStyleLst>
+      <a:effectStyleLst>
+        <a:effectStyle>
+          <a:effectLst/>
+        </a:effectStyle>
+        <a:effectStyle>
+          <a:effectLst/>
+        </a:effectStyle>
+        <a:effectStyle>
+          <a:effectLst>
+            <a:outerShdw blurRad="57150" dist="19050" dir="5400000" algn="ctr" rotWithShape="0">
+              <a:srgbClr val="000000">
+                <a:alpha val="63000"/>
+              </a:srgbClr>
+            </a:outerShdw>
+          </a:effectLst>
+        </a:effectStyle>
+      </a:effectStyleLst>
+      <a:bgFillStyleLst>
+        <a:solidFill>
+          <a:schemeClr val="phClr"/>
+        </a:solidFill>
+        <a:solidFill>
+          <a:schemeClr val="phClr">
+            <a:tint val="95000"/>
+            <a:satMod val="170000"/>
+          </a:schemeClr>
+        </a:solidFill>
+        <a:gradFill rotWithShape="1">
+          <a:gsLst>
+            <a:gs pos="0">
+              <a:schemeClr val="phClr">
+                <a:tint val="93000"/>
+                <a:satMod val="150000"/>
+                <a:shade val="98000"/>
+                <a:lumMod val="102000"/>
+              </a:schemeClr>
+            </a:gs>
+            <a:gs pos="50000">
+              <a:schemeClr val="phClr">
+                <a:tint val="98000"/>
+                <a:satMod val="130000"/>
+                <a:shade val="90000"/>
+                <a:lumMod val="103000"/>
+              </a:schemeClr>
+            </a:gs>
+            <a:gs pos="100000">
+              <a:schemeClr val="phClr">
+                <a:shade val="63000"/>
+                <a:satMod val="120000"/>
+              </a:schemeClr>
+            </a:gs>
+          </a:gsLst>
+          <a:lin ang="5400000" scaled="0"/>
+        </a:gradFill>
+      </a:bgFillStyleLst>
+    </a:fmtScheme>
+  </a:themeElements>
+  <a:objectDefaults>
+    <a:lnDef>
+      <a:spPr/>
+      <a:bodyPr/>
+      <a:lstStyle/>
+      <a:style>
+        <a:lnRef idx="2">
+          <a:schemeClr val="accent1"/>
+        </a:lnRef>
+        <a:fillRef idx="0">
+          <a:schemeClr val="accent1"/>
+        </a:fillRef>
+        <a:effectRef idx="1">
+          <a:schemeClr val="accent1"/>
+        </a:effectRef>
+        <a:fontRef idx="minor">
+          <a:schemeClr val="tx1"/>
+        </a:fontRef>
+      </a:style>
+    </a:lnDef>
+  </a:objectDefaults>
+  <a:extraClrSchemeLst/>
+  <a:extLst>
+    <a:ext uri="{05A4C25C-085E-4340-85A3-A5531E510DB2}">
+      <thm15:themeFamily xmlns:thm15="http://schemas.microsoft.com/office/thememl/2012/main" name="Office Theme" id="{2E142A2C-CD16-42D6-873A-C26D2A0506FA}" vid="{1BDDFF52-6CD6-40A5-AB3C-68EB2F1E4D0A}"/>
+    </a:ext>
+  </a:extLst>
+</a:theme>
 </file>
</xml_diff>